<commit_message>
feat: add speaker notes to all 25 slides
Added speaker_notes key to every slide dict in src/content.py and
updated src/create_ppt.py to write notes to each slide's notes_slide.

Co-Authored-By: Claude Sonnet 4.6 <noreply@anthropic.com>
</commit_message>
<xml_diff>
--- a/output/network-card-csi.pptx
+++ b/output/network-card-csi.pptx
@@ -6,30 +6,30 @@
   </p:sldMasterIdLst>
   <p:sldIdLst>
     <p:sldId id="256" r:id="rId7"/>
-    <p:sldId id="257" r:id="rId8"/>
-    <p:sldId id="258" r:id="rId9"/>
-    <p:sldId id="259" r:id="rId10"/>
-    <p:sldId id="260" r:id="rId11"/>
-    <p:sldId id="261" r:id="rId12"/>
-    <p:sldId id="262" r:id="rId13"/>
-    <p:sldId id="263" r:id="rId14"/>
-    <p:sldId id="264" r:id="rId15"/>
-    <p:sldId id="265" r:id="rId16"/>
-    <p:sldId id="266" r:id="rId17"/>
-    <p:sldId id="267" r:id="rId18"/>
-    <p:sldId id="268" r:id="rId19"/>
-    <p:sldId id="269" r:id="rId20"/>
-    <p:sldId id="270" r:id="rId21"/>
-    <p:sldId id="271" r:id="rId22"/>
-    <p:sldId id="272" r:id="rId23"/>
-    <p:sldId id="273" r:id="rId24"/>
-    <p:sldId id="274" r:id="rId25"/>
-    <p:sldId id="275" r:id="rId26"/>
-    <p:sldId id="276" r:id="rId27"/>
-    <p:sldId id="277" r:id="rId28"/>
-    <p:sldId id="278" r:id="rId29"/>
-    <p:sldId id="279" r:id="rId30"/>
-    <p:sldId id="280" r:id="rId31"/>
+    <p:sldId id="257" r:id="rId9"/>
+    <p:sldId id="258" r:id="rId10"/>
+    <p:sldId id="259" r:id="rId11"/>
+    <p:sldId id="260" r:id="rId12"/>
+    <p:sldId id="261" r:id="rId13"/>
+    <p:sldId id="262" r:id="rId14"/>
+    <p:sldId id="263" r:id="rId15"/>
+    <p:sldId id="264" r:id="rId16"/>
+    <p:sldId id="265" r:id="rId17"/>
+    <p:sldId id="266" r:id="rId18"/>
+    <p:sldId id="267" r:id="rId19"/>
+    <p:sldId id="268" r:id="rId20"/>
+    <p:sldId id="269" r:id="rId21"/>
+    <p:sldId id="270" r:id="rId22"/>
+    <p:sldId id="271" r:id="rId23"/>
+    <p:sldId id="272" r:id="rId24"/>
+    <p:sldId id="273" r:id="rId25"/>
+    <p:sldId id="274" r:id="rId26"/>
+    <p:sldId id="275" r:id="rId27"/>
+    <p:sldId id="276" r:id="rId28"/>
+    <p:sldId id="277" r:id="rId29"/>
+    <p:sldId id="278" r:id="rId30"/>
+    <p:sldId id="279" r:id="rId31"/>
+    <p:sldId id="280" r:id="rId32"/>
   </p:sldIdLst>
   <p:sldSz cx="9144000" cy="5143500" type="screen4x3"/>
   <p:notesSz cx="6858000" cy="9144000"/>
@@ -129,6 +129,2532 @@
     </a:lvl9pPr>
   </p:defaultTextStyle>
 </p:presentation>
+</file>
+
+<file path=ppt/notesMasters/notesMaster1.xml><?xml version="1.0" encoding="utf-8"?>
+<p:notesMaster xmlns:a="http://schemas.openxmlformats.org/drawingml/2006/main" xmlns:p="http://schemas.openxmlformats.org/presentationml/2006/main" xmlns:r="http://schemas.openxmlformats.org/officeDocument/2006/relationships">
+  <p:cSld>
+    <p:bg>
+      <p:bgRef idx="1001">
+        <a:schemeClr val="bg1"/>
+      </p:bgRef>
+    </p:bg>
+    <p:spTree>
+      <p:nvGrpSpPr>
+        <p:cNvPr id="1" name=""/>
+        <p:cNvGrpSpPr/>
+        <p:nvPr/>
+      </p:nvGrpSpPr>
+      <p:grpSpPr>
+        <a:xfrm>
+          <a:off x="0" y="0"/>
+          <a:ext cx="0" cy="0"/>
+          <a:chOff x="0" y="0"/>
+          <a:chExt cx="0" cy="0"/>
+        </a:xfrm>
+      </p:grpSpPr>
+      <p:sp>
+        <p:nvSpPr>
+          <p:cNvPr id="2" name="Header Placeholder 1"/>
+          <p:cNvSpPr>
+            <a:spLocks noGrp="1"/>
+          </p:cNvSpPr>
+          <p:nvPr>
+            <p:ph type="hdr" sz="quarter"/>
+          </p:nvPr>
+        </p:nvSpPr>
+        <p:spPr>
+          <a:xfrm>
+            <a:off x="0" y="0"/>
+            <a:ext cx="2971800" cy="457200"/>
+          </a:xfrm>
+          <a:prstGeom prst="rect">
+            <a:avLst/>
+          </a:prstGeom>
+        </p:spPr>
+        <p:txBody>
+          <a:bodyPr vert="horz" lIns="91440" tIns="45720" rIns="91440" bIns="45720" rtlCol="0"/>
+          <a:lstStyle>
+            <a:lvl1pPr algn="l">
+              <a:defRPr sz="1200"/>
+            </a:lvl1pPr>
+          </a:lstStyle>
+          <a:p>
+            <a:endParaRPr lang="en-US"/>
+          </a:p>
+        </p:txBody>
+      </p:sp>
+      <p:sp>
+        <p:nvSpPr>
+          <p:cNvPr id="3" name="Date Placeholder 2"/>
+          <p:cNvSpPr>
+            <a:spLocks noGrp="1"/>
+          </p:cNvSpPr>
+          <p:nvPr>
+            <p:ph type="dt" idx="1"/>
+          </p:nvPr>
+        </p:nvSpPr>
+        <p:spPr>
+          <a:xfrm>
+            <a:off x="3884613" y="0"/>
+            <a:ext cx="2971800" cy="457200"/>
+          </a:xfrm>
+          <a:prstGeom prst="rect">
+            <a:avLst/>
+          </a:prstGeom>
+        </p:spPr>
+        <p:txBody>
+          <a:bodyPr vert="horz" lIns="91440" tIns="45720" rIns="91440" bIns="45720" rtlCol="0"/>
+          <a:lstStyle>
+            <a:lvl1pPr algn="r">
+              <a:defRPr sz="1200"/>
+            </a:lvl1pPr>
+          </a:lstStyle>
+          <a:p>
+            <a:fld id="{0F89C1C7-3DCD-1040-A9CF-14679D8B5DDD}" type="datetimeFigureOut">
+              <a:rPr lang="en-US" smtClean="0"/>
+              <a:t>10/17/16</a:t>
+            </a:fld>
+            <a:endParaRPr lang="en-US"/>
+          </a:p>
+        </p:txBody>
+      </p:sp>
+      <p:sp>
+        <p:nvSpPr>
+          <p:cNvPr id="4" name="Slide Image Placeholder 3"/>
+          <p:cNvSpPr>
+            <a:spLocks noGrp="1" noRot="1" noChangeAspect="1"/>
+          </p:cNvSpPr>
+          <p:nvPr>
+            <p:ph type="sldImg" idx="2"/>
+          </p:nvPr>
+        </p:nvSpPr>
+        <p:spPr>
+          <a:xfrm>
+            <a:off x="1143000" y="685800"/>
+            <a:ext cx="4572000" cy="3429000"/>
+          </a:xfrm>
+          <a:prstGeom prst="rect">
+            <a:avLst/>
+          </a:prstGeom>
+          <a:noFill/>
+          <a:ln w="12700">
+            <a:solidFill>
+              <a:prstClr val="black"/>
+            </a:solidFill>
+          </a:ln>
+        </p:spPr>
+        <p:txBody>
+          <a:bodyPr vert="horz" lIns="91440" tIns="45720" rIns="91440" bIns="45720" rtlCol="0" anchor="ctr"/>
+          <a:lstStyle/>
+          <a:p>
+            <a:endParaRPr lang="en-US"/>
+          </a:p>
+        </p:txBody>
+      </p:sp>
+      <p:sp>
+        <p:nvSpPr>
+          <p:cNvPr id="5" name="Notes Placeholder 4"/>
+          <p:cNvSpPr>
+            <a:spLocks noGrp="1"/>
+          </p:cNvSpPr>
+          <p:nvPr>
+            <p:ph type="body" sz="quarter" idx="3"/>
+          </p:nvPr>
+        </p:nvSpPr>
+        <p:spPr>
+          <a:xfrm>
+            <a:off x="685800" y="4343400"/>
+            <a:ext cx="5486400" cy="4114800"/>
+          </a:xfrm>
+          <a:prstGeom prst="rect">
+            <a:avLst/>
+          </a:prstGeom>
+        </p:spPr>
+        <p:txBody>
+          <a:bodyPr vert="horz" lIns="91440" tIns="45720" rIns="91440" bIns="45720" rtlCol="0"/>
+          <a:lstStyle/>
+          <a:p>
+            <a:pPr lvl="0"/>
+            <a:r>
+              <a:rPr lang="en-US" smtClean="0"/>
+              <a:t>Click to edit Master text styles</a:t>
+            </a:r>
+          </a:p>
+          <a:p>
+            <a:pPr lvl="1"/>
+            <a:r>
+              <a:rPr lang="en-US" smtClean="0"/>
+              <a:t>Second level</a:t>
+            </a:r>
+          </a:p>
+          <a:p>
+            <a:pPr lvl="2"/>
+            <a:r>
+              <a:rPr lang="en-US" smtClean="0"/>
+              <a:t>Third level</a:t>
+            </a:r>
+          </a:p>
+          <a:p>
+            <a:pPr lvl="3"/>
+            <a:r>
+              <a:rPr lang="en-US" smtClean="0"/>
+              <a:t>Fourth level</a:t>
+            </a:r>
+          </a:p>
+          <a:p>
+            <a:pPr lvl="4"/>
+            <a:r>
+              <a:rPr lang="en-US" smtClean="0"/>
+              <a:t>Fifth level</a:t>
+            </a:r>
+            <a:endParaRPr lang="en-US"/>
+          </a:p>
+        </p:txBody>
+      </p:sp>
+      <p:sp>
+        <p:nvSpPr>
+          <p:cNvPr id="6" name="Footer Placeholder 5"/>
+          <p:cNvSpPr>
+            <a:spLocks noGrp="1"/>
+          </p:cNvSpPr>
+          <p:nvPr>
+            <p:ph type="ftr" sz="quarter" idx="4"/>
+          </p:nvPr>
+        </p:nvSpPr>
+        <p:spPr>
+          <a:xfrm>
+            <a:off x="0" y="8685213"/>
+            <a:ext cx="2971800" cy="457200"/>
+          </a:xfrm>
+          <a:prstGeom prst="rect">
+            <a:avLst/>
+          </a:prstGeom>
+        </p:spPr>
+        <p:txBody>
+          <a:bodyPr vert="horz" lIns="91440" tIns="45720" rIns="91440" bIns="45720" rtlCol="0" anchor="b"/>
+          <a:lstStyle>
+            <a:lvl1pPr algn="l">
+              <a:defRPr sz="1200"/>
+            </a:lvl1pPr>
+          </a:lstStyle>
+          <a:p>
+            <a:endParaRPr lang="en-US"/>
+          </a:p>
+        </p:txBody>
+      </p:sp>
+      <p:sp>
+        <p:nvSpPr>
+          <p:cNvPr id="7" name="Slide Number Placeholder 6"/>
+          <p:cNvSpPr>
+            <a:spLocks noGrp="1"/>
+          </p:cNvSpPr>
+          <p:nvPr>
+            <p:ph type="sldNum" sz="quarter" idx="5"/>
+          </p:nvPr>
+        </p:nvSpPr>
+        <p:spPr>
+          <a:xfrm>
+            <a:off x="3884613" y="8685213"/>
+            <a:ext cx="2971800" cy="457200"/>
+          </a:xfrm>
+          <a:prstGeom prst="rect">
+            <a:avLst/>
+          </a:prstGeom>
+        </p:spPr>
+        <p:txBody>
+          <a:bodyPr vert="horz" lIns="91440" tIns="45720" rIns="91440" bIns="45720" rtlCol="0" anchor="b"/>
+          <a:lstStyle>
+            <a:lvl1pPr algn="r">
+              <a:defRPr sz="1200"/>
+            </a:lvl1pPr>
+          </a:lstStyle>
+          <a:p>
+            <a:fld id="{BB5E49A5-4136-284D-997B-48E1D791AD67}" type="slidenum">
+              <a:rPr lang="en-US" smtClean="0"/>
+              <a:t>‹#›</a:t>
+            </a:fld>
+            <a:endParaRPr lang="en-US"/>
+          </a:p>
+        </p:txBody>
+      </p:sp>
+    </p:spTree>
+    <p:extLst>
+      <p:ext uri="{BB962C8B-B14F-4D97-AF65-F5344CB8AC3E}">
+        <p14:creationId xmlns:p14="http://schemas.microsoft.com/office/powerpoint/2010/main" val="2623252185"/>
+      </p:ext>
+    </p:extLst>
+  </p:cSld>
+  <p:clrMap bg1="lt1" tx1="dk1" bg2="lt2" tx2="dk2" accent1="accent1" accent2="accent2" accent3="accent3" accent4="accent4" accent5="accent5" accent6="accent6" hlink="hlink" folHlink="folHlink"/>
+  <p:notesStyle>
+    <a:lvl1pPr marL="0" algn="l" defTabSz="457200" rtl="0" eaLnBrk="1" latinLnBrk="0" hangingPunct="1">
+      <a:defRPr sz="1200" kern="1200">
+        <a:solidFill>
+          <a:schemeClr val="tx1"/>
+        </a:solidFill>
+        <a:latin typeface="+mn-lt"/>
+        <a:ea typeface="+mn-ea"/>
+        <a:cs typeface="+mn-cs"/>
+      </a:defRPr>
+    </a:lvl1pPr>
+    <a:lvl2pPr marL="457200" algn="l" defTabSz="457200" rtl="0" eaLnBrk="1" latinLnBrk="0" hangingPunct="1">
+      <a:defRPr sz="1200" kern="1200">
+        <a:solidFill>
+          <a:schemeClr val="tx1"/>
+        </a:solidFill>
+        <a:latin typeface="+mn-lt"/>
+        <a:ea typeface="+mn-ea"/>
+        <a:cs typeface="+mn-cs"/>
+      </a:defRPr>
+    </a:lvl2pPr>
+    <a:lvl3pPr marL="914400" algn="l" defTabSz="457200" rtl="0" eaLnBrk="1" latinLnBrk="0" hangingPunct="1">
+      <a:defRPr sz="1200" kern="1200">
+        <a:solidFill>
+          <a:schemeClr val="tx1"/>
+        </a:solidFill>
+        <a:latin typeface="+mn-lt"/>
+        <a:ea typeface="+mn-ea"/>
+        <a:cs typeface="+mn-cs"/>
+      </a:defRPr>
+    </a:lvl3pPr>
+    <a:lvl4pPr marL="1371600" algn="l" defTabSz="457200" rtl="0" eaLnBrk="1" latinLnBrk="0" hangingPunct="1">
+      <a:defRPr sz="1200" kern="1200">
+        <a:solidFill>
+          <a:schemeClr val="tx1"/>
+        </a:solidFill>
+        <a:latin typeface="+mn-lt"/>
+        <a:ea typeface="+mn-ea"/>
+        <a:cs typeface="+mn-cs"/>
+      </a:defRPr>
+    </a:lvl4pPr>
+    <a:lvl5pPr marL="1828800" algn="l" defTabSz="457200" rtl="0" eaLnBrk="1" latinLnBrk="0" hangingPunct="1">
+      <a:defRPr sz="1200" kern="1200">
+        <a:solidFill>
+          <a:schemeClr val="tx1"/>
+        </a:solidFill>
+        <a:latin typeface="+mn-lt"/>
+        <a:ea typeface="+mn-ea"/>
+        <a:cs typeface="+mn-cs"/>
+      </a:defRPr>
+    </a:lvl5pPr>
+    <a:lvl6pPr marL="2286000" algn="l" defTabSz="457200" rtl="0" eaLnBrk="1" latinLnBrk="0" hangingPunct="1">
+      <a:defRPr sz="1200" kern="1200">
+        <a:solidFill>
+          <a:schemeClr val="tx1"/>
+        </a:solidFill>
+        <a:latin typeface="+mn-lt"/>
+        <a:ea typeface="+mn-ea"/>
+        <a:cs typeface="+mn-cs"/>
+      </a:defRPr>
+    </a:lvl6pPr>
+    <a:lvl7pPr marL="2743200" algn="l" defTabSz="457200" rtl="0" eaLnBrk="1" latinLnBrk="0" hangingPunct="1">
+      <a:defRPr sz="1200" kern="1200">
+        <a:solidFill>
+          <a:schemeClr val="tx1"/>
+        </a:solidFill>
+        <a:latin typeface="+mn-lt"/>
+        <a:ea typeface="+mn-ea"/>
+        <a:cs typeface="+mn-cs"/>
+      </a:defRPr>
+    </a:lvl7pPr>
+    <a:lvl8pPr marL="3200400" algn="l" defTabSz="457200" rtl="0" eaLnBrk="1" latinLnBrk="0" hangingPunct="1">
+      <a:defRPr sz="1200" kern="1200">
+        <a:solidFill>
+          <a:schemeClr val="tx1"/>
+        </a:solidFill>
+        <a:latin typeface="+mn-lt"/>
+        <a:ea typeface="+mn-ea"/>
+        <a:cs typeface="+mn-cs"/>
+      </a:defRPr>
+    </a:lvl8pPr>
+    <a:lvl9pPr marL="3657600" algn="l" defTabSz="457200" rtl="0" eaLnBrk="1" latinLnBrk="0" hangingPunct="1">
+      <a:defRPr sz="1200" kern="1200">
+        <a:solidFill>
+          <a:schemeClr val="tx1"/>
+        </a:solidFill>
+        <a:latin typeface="+mn-lt"/>
+        <a:ea typeface="+mn-ea"/>
+        <a:cs typeface="+mn-cs"/>
+      </a:defRPr>
+    </a:lvl9pPr>
+  </p:notesStyle>
+</p:notesMaster>
+</file>
+
+<file path=ppt/notesSlides/notesSlide1.xml><?xml version="1.0" encoding="utf-8"?>
+<p:notes xmlns:a="http://schemas.openxmlformats.org/drawingml/2006/main" xmlns:p="http://schemas.openxmlformats.org/presentationml/2006/main" xmlns:r="http://schemas.openxmlformats.org/officeDocument/2006/relationships">
+  <p:cSld>
+    <p:spTree>
+      <p:nvGrpSpPr>
+        <p:cNvPr id="1" name=""/>
+        <p:cNvGrpSpPr/>
+        <p:nvPr/>
+      </p:nvGrpSpPr>
+      <p:grpSpPr>
+        <a:xfrm>
+          <a:off x="0" y="0"/>
+          <a:ext cx="0" cy="0"/>
+          <a:chOff x="0" y="0"/>
+          <a:chExt cx="0" cy="0"/>
+        </a:xfrm>
+      </p:grpSpPr>
+      <p:sp>
+        <p:nvSpPr>
+          <p:cNvPr id="2" name="Slide Image Placeholder 1"/>
+          <p:cNvSpPr>
+            <a:spLocks noGrp="1"/>
+          </p:cNvSpPr>
+          <p:nvPr>
+            <p:ph type="sldImg" idx="2"/>
+          </p:nvPr>
+        </p:nvSpPr>
+        <p:spPr/>
+      </p:sp>
+      <p:sp>
+        <p:nvSpPr>
+          <p:cNvPr id="3" name="Notes Placeholder 2"/>
+          <p:cNvSpPr>
+            <a:spLocks noGrp="1"/>
+          </p:cNvSpPr>
+          <p:nvPr>
+            <p:ph type="body" idx="3" sz="quarter"/>
+          </p:nvPr>
+        </p:nvSpPr>
+        <p:spPr/>
+        <p:txBody>
+          <a:bodyPr/>
+          <a:lstStyle/>
+          <a:p>
+            <a:r>
+              <a:t>大家好，今天的主題是「網卡與 OS 層的關係」。我們會從 RF 工程師最熟悉的 PHY 層出發，一路向上追溯到 Windows 的應用程式層，最後回答一個很多 RF 工程師都碰過的問題：為什麼在 Windows 上無法取得網卡的 CSI 資料？</a:t>
+            </a:r>
+          </a:p>
+          <a:p/>
+          <a:p>
+            <a:r>
+              <a:t>這份投影片設計給有 PHY/MAC 背景的工程師，所以我不會花太多時間在 RF 基礎，而是聚焦在 OS 軟體層的架構與限制。</a:t>
+            </a:r>
+          </a:p>
+        </p:txBody>
+      </p:sp>
+      <p:sp>
+        <p:nvSpPr>
+          <p:cNvPr id="4" name="Slide Number Placeholder 3"/>
+          <p:cNvSpPr>
+            <a:spLocks noGrp="1"/>
+          </p:cNvSpPr>
+          <p:nvPr>
+            <p:ph type="sldNum" idx="5" sz="quarter"/>
+          </p:nvPr>
+        </p:nvSpPr>
+        <p:spPr/>
+      </p:sp>
+    </p:spTree>
+  </p:cSld>
+  <p:clrMapOvr>
+    <a:masterClrMapping/>
+  </p:clrMapOvr>
+</p:notes>
+</file>
+
+<file path=ppt/notesSlides/notesSlide10.xml><?xml version="1.0" encoding="utf-8"?>
+<p:notes xmlns:a="http://schemas.openxmlformats.org/drawingml/2006/main" xmlns:p="http://schemas.openxmlformats.org/presentationml/2006/main" xmlns:r="http://schemas.openxmlformats.org/officeDocument/2006/relationships">
+  <p:cSld>
+    <p:spTree>
+      <p:nvGrpSpPr>
+        <p:cNvPr id="1" name=""/>
+        <p:cNvGrpSpPr/>
+        <p:nvPr/>
+      </p:nvGrpSpPr>
+      <p:grpSpPr>
+        <a:xfrm>
+          <a:off x="0" y="0"/>
+          <a:ext cx="0" cy="0"/>
+          <a:chOff x="0" y="0"/>
+          <a:chExt cx="0" cy="0"/>
+        </a:xfrm>
+      </p:grpSpPr>
+      <p:sp>
+        <p:nvSpPr>
+          <p:cNvPr id="2" name="Slide Image Placeholder 1"/>
+          <p:cNvSpPr>
+            <a:spLocks noGrp="1"/>
+          </p:cNvSpPr>
+          <p:nvPr>
+            <p:ph type="sldImg" idx="2"/>
+          </p:nvPr>
+        </p:nvSpPr>
+        <p:spPr/>
+      </p:sp>
+      <p:sp>
+        <p:nvSpPr>
+          <p:cNvPr id="3" name="Notes Placeholder 2"/>
+          <p:cNvSpPr>
+            <a:spLocks noGrp="1"/>
+          </p:cNvSpPr>
+          <p:nvPr>
+            <p:ph type="body" idx="3" sz="quarter"/>
+          </p:nvPr>
+        </p:nvSpPr>
+        <p:spPr/>
+        <p:txBody>
+          <a:bodyPr/>
+          <a:lstStyle/>
+          <a:p>
+            <a:r>
+              <a:t>nwifi.sys 是 Windows Native WiFi 驅動，位於 OEM.sys 上方。它的職責是管理 802.11 的連線狀態。</a:t>
+            </a:r>
+          </a:p>
+          <a:p/>
+          <a:p>
+            <a:r>
+              <a:t>認證、漫遊、省電、掃描——這些都是 nwifi.sys 負責的。它向上暴露兩種介面：一是給應用程式用的 Native WiFi API，二是給 tcpip.sys 用的 NDIS OID 介面。</a:t>
+            </a:r>
+          </a:p>
+          <a:p/>
+          <a:p>
+            <a:r>
+              <a:t>重點：nwifi.sys 的設計目標是「管理 WiFi 連線」，不是「提供 RF 量測資料」。它不處理、不儲存、也不轉發任何 PHY 層的原始資訊。</a:t>
+            </a:r>
+          </a:p>
+        </p:txBody>
+      </p:sp>
+      <p:sp>
+        <p:nvSpPr>
+          <p:cNvPr id="4" name="Slide Number Placeholder 3"/>
+          <p:cNvSpPr>
+            <a:spLocks noGrp="1"/>
+          </p:cNvSpPr>
+          <p:nvPr>
+            <p:ph type="sldNum" idx="5" sz="quarter"/>
+          </p:nvPr>
+        </p:nvSpPr>
+        <p:spPr/>
+      </p:sp>
+    </p:spTree>
+  </p:cSld>
+  <p:clrMapOvr>
+    <a:masterClrMapping/>
+  </p:clrMapOvr>
+</p:notes>
+</file>
+
+<file path=ppt/notesSlides/notesSlide11.xml><?xml version="1.0" encoding="utf-8"?>
+<p:notes xmlns:a="http://schemas.openxmlformats.org/drawingml/2006/main" xmlns:p="http://schemas.openxmlformats.org/presentationml/2006/main" xmlns:r="http://schemas.openxmlformats.org/officeDocument/2006/relationships">
+  <p:cSld>
+    <p:spTree>
+      <p:nvGrpSpPr>
+        <p:cNvPr id="1" name=""/>
+        <p:cNvGrpSpPr/>
+        <p:nvPr/>
+      </p:nvGrpSpPr>
+      <p:grpSpPr>
+        <a:xfrm>
+          <a:off x="0" y="0"/>
+          <a:ext cx="0" cy="0"/>
+          <a:chOff x="0" y="0"/>
+          <a:chExt cx="0" cy="0"/>
+        </a:xfrm>
+      </p:grpSpPr>
+      <p:sp>
+        <p:nvSpPr>
+          <p:cNvPr id="2" name="Slide Image Placeholder 1"/>
+          <p:cNvSpPr>
+            <a:spLocks noGrp="1"/>
+          </p:cNvSpPr>
+          <p:nvPr>
+            <p:ph type="sldImg" idx="2"/>
+          </p:nvPr>
+        </p:nvSpPr>
+        <p:spPr/>
+      </p:sp>
+      <p:sp>
+        <p:nvSpPr>
+          <p:cNvPr id="3" name="Notes Placeholder 2"/>
+          <p:cNvSpPr>
+            <a:spLocks noGrp="1"/>
+          </p:cNvSpPr>
+          <p:nvPr>
+            <p:ph type="body" idx="3" sz="quarter"/>
+          </p:nvPr>
+        </p:nvSpPr>
+        <p:spPr/>
+        <p:txBody>
+          <a:bodyPr/>
+          <a:lstStyle/>
+          <a:p>
+            <a:r>
+              <a:t>這張兩欄表格很清楚地展示了 nwifi.sys 的抽象化代價。</a:t>
+            </a:r>
+          </a:p>
+          <a:p/>
+          <a:p>
+            <a:r>
+              <a:t>左邊是它向上暴露的資訊：SSID、RSSI、連線狀態、安全性設定、頻道、連線速率。這些對於管理 WiFi 連線已經足夠。</a:t>
+            </a:r>
+          </a:p>
+          <a:p/>
+          <a:p>
+            <a:r>
+              <a:t>右邊是它不暴露的資訊：CSI、原始 IQ 樣本、每根天線的獨立 RSSI、噪聲圖、硬體時間戳。這些都是 RF 量測需要的資料。</a:t>
+            </a:r>
+          </a:p>
+          <a:p/>
+          <a:p>
+            <a:r>
+              <a:t>從 nwifi.sys 向上，這些 PHY 層資訊已經被永久丟棄，無法恢復。這是架構設計的結果，不是 bug。</a:t>
+            </a:r>
+          </a:p>
+        </p:txBody>
+      </p:sp>
+      <p:sp>
+        <p:nvSpPr>
+          <p:cNvPr id="4" name="Slide Number Placeholder 3"/>
+          <p:cNvSpPr>
+            <a:spLocks noGrp="1"/>
+          </p:cNvSpPr>
+          <p:nvPr>
+            <p:ph type="sldNum" idx="5" sz="quarter"/>
+          </p:nvPr>
+        </p:nvSpPr>
+        <p:spPr/>
+      </p:sp>
+    </p:spTree>
+  </p:cSld>
+  <p:clrMapOvr>
+    <a:masterClrMapping/>
+  </p:clrMapOvr>
+</p:notes>
+</file>
+
+<file path=ppt/notesSlides/notesSlide12.xml><?xml version="1.0" encoding="utf-8"?>
+<p:notes xmlns:a="http://schemas.openxmlformats.org/drawingml/2006/main" xmlns:p="http://schemas.openxmlformats.org/presentationml/2006/main" xmlns:r="http://schemas.openxmlformats.org/officeDocument/2006/relationships">
+  <p:cSld>
+    <p:spTree>
+      <p:nvGrpSpPr>
+        <p:cNvPr id="1" name=""/>
+        <p:cNvGrpSpPr/>
+        <p:nvPr/>
+      </p:nvGrpSpPr>
+      <p:grpSpPr>
+        <a:xfrm>
+          <a:off x="0" y="0"/>
+          <a:ext cx="0" cy="0"/>
+          <a:chOff x="0" y="0"/>
+          <a:chExt cx="0" cy="0"/>
+        </a:xfrm>
+      </p:grpSpPr>
+      <p:sp>
+        <p:nvSpPr>
+          <p:cNvPr id="2" name="Slide Image Placeholder 1"/>
+          <p:cNvSpPr>
+            <a:spLocks noGrp="1"/>
+          </p:cNvSpPr>
+          <p:nvPr>
+            <p:ph type="sldImg" idx="2"/>
+          </p:nvPr>
+        </p:nvSpPr>
+        <p:spPr/>
+      </p:sp>
+      <p:sp>
+        <p:nvSpPr>
+          <p:cNvPr id="3" name="Notes Placeholder 2"/>
+          <p:cNvSpPr>
+            <a:spLocks noGrp="1"/>
+          </p:cNvSpPr>
+          <p:nvPr>
+            <p:ph type="body" idx="3" sz="quarter"/>
+          </p:nvPr>
+        </p:nvSpPr>
+        <p:spPr/>
+        <p:txBody>
+          <a:bodyPr/>
+          <a:lstStyle/>
+          <a:p>
+            <a:r>
+              <a:t>理解了 OID 機制，就能理解為什麼 CSI 無法透過標準介面取得。</a:t>
+            </a:r>
+          </a:p>
+          <a:p/>
+          <a:p>
+            <a:r>
+              <a:t>NDIS 的核心設計目標是「跨廠商通用性」——讓 Intel 的網卡和 Broadcom 的網卡都可以用相同的 API。這個目標需要取最大公約數：只定義所有廠商都支援的功能。</a:t>
+            </a:r>
+          </a:p>
+          <a:p/>
+          <a:p>
+            <a:r>
+              <a:t>OID_802_11 系列定義了 SSID、RSSI、掃描等標準操作。但 CSI 是廠商私有的 PHY 細節，不同廠商的 CSI 格式完全不同（Intel 5300 是 30 個子載波群組，Atheros AR9380 是 56 個子載波）。把這種廠商差異標準化是不可能的，所以 NDIS 根本沒有嘗試。</a:t>
+            </a:r>
+          </a:p>
+          <a:p/>
+          <a:p>
+            <a:r>
+              <a:t>這就是 NDIS 通用性設計的代價。</a:t>
+            </a:r>
+          </a:p>
+        </p:txBody>
+      </p:sp>
+      <p:sp>
+        <p:nvSpPr>
+          <p:cNvPr id="4" name="Slide Number Placeholder 3"/>
+          <p:cNvSpPr>
+            <a:spLocks noGrp="1"/>
+          </p:cNvSpPr>
+          <p:nvPr>
+            <p:ph type="sldNum" idx="5" sz="quarter"/>
+          </p:nvPr>
+        </p:nvSpPr>
+        <p:spPr/>
+      </p:sp>
+    </p:spTree>
+  </p:cSld>
+  <p:clrMapOvr>
+    <a:masterClrMapping/>
+  </p:clrMapOvr>
+</p:notes>
+</file>
+
+<file path=ppt/notesSlides/notesSlide13.xml><?xml version="1.0" encoding="utf-8"?>
+<p:notes xmlns:a="http://schemas.openxmlformats.org/drawingml/2006/main" xmlns:p="http://schemas.openxmlformats.org/presentationml/2006/main" xmlns:r="http://schemas.openxmlformats.org/officeDocument/2006/relationships">
+  <p:cSld>
+    <p:spTree>
+      <p:nvGrpSpPr>
+        <p:cNvPr id="1" name=""/>
+        <p:cNvGrpSpPr/>
+        <p:nvPr/>
+      </p:nvGrpSpPr>
+      <p:grpSpPr>
+        <a:xfrm>
+          <a:off x="0" y="0"/>
+          <a:ext cx="0" cy="0"/>
+          <a:chOff x="0" y="0"/>
+          <a:chExt cx="0" cy="0"/>
+        </a:xfrm>
+      </p:grpSpPr>
+      <p:sp>
+        <p:nvSpPr>
+          <p:cNvPr id="2" name="Slide Image Placeholder 1"/>
+          <p:cNvSpPr>
+            <a:spLocks noGrp="1"/>
+          </p:cNvSpPr>
+          <p:nvPr>
+            <p:ph type="sldImg" idx="2"/>
+          </p:nvPr>
+        </p:nvSpPr>
+        <p:spPr/>
+      </p:sp>
+      <p:sp>
+        <p:nvSpPr>
+          <p:cNvPr id="3" name="Notes Placeholder 2"/>
+          <p:cNvSpPr>
+            <a:spLocks noGrp="1"/>
+          </p:cNvSpPr>
+          <p:nvPr>
+            <p:ph type="body" idx="3" sz="quarter"/>
+          </p:nvPr>
+        </p:nvSpPr>
+        <p:spPr/>
+        <p:txBody>
+          <a:bodyPr/>
+          <a:lstStyle/>
+          <a:p>
+            <a:r>
+              <a:t>Windows 10 引入了 WDI 作為新的 WiFi 驅動模型。WDI 把驅動分成兩部分：IHV 廠商負責的 User Mode 元件，和 WDI 框架的 Kernel Mode 元件。</a:t>
+            </a:r>
+          </a:p>
+          <a:p/>
+          <a:p>
+            <a:r>
+              <a:t>這個架構的優點是：User Mode 的 crash 不會導致藍屏，大幅提升系統穩定性，也簡化了廠商的驅動開發。</a:t>
+            </a:r>
+          </a:p>
+          <a:p/>
+          <a:p>
+            <a:r>
+              <a:t>但是——WDI 的 Task 和 Property 定義完全沒有包含 CSI 相關的介面。WDI 是架構上的改進，不是解決 CSI 取得問題的嘗試。所以即使升級到 WDI 模型，CSI 依然無法取得。</a:t>
+            </a:r>
+          </a:p>
+        </p:txBody>
+      </p:sp>
+      <p:sp>
+        <p:nvSpPr>
+          <p:cNvPr id="4" name="Slide Number Placeholder 3"/>
+          <p:cNvSpPr>
+            <a:spLocks noGrp="1"/>
+          </p:cNvSpPr>
+          <p:nvPr>
+            <p:ph type="sldNum" idx="5" sz="quarter"/>
+          </p:nvPr>
+        </p:nvSpPr>
+        <p:spPr/>
+      </p:sp>
+    </p:spTree>
+  </p:cSld>
+  <p:clrMapOvr>
+    <a:masterClrMapping/>
+  </p:clrMapOvr>
+</p:notes>
+</file>
+
+<file path=ppt/notesSlides/notesSlide14.xml><?xml version="1.0" encoding="utf-8"?>
+<p:notes xmlns:a="http://schemas.openxmlformats.org/drawingml/2006/main" xmlns:p="http://schemas.openxmlformats.org/presentationml/2006/main" xmlns:r="http://schemas.openxmlformats.org/officeDocument/2006/relationships">
+  <p:cSld>
+    <p:spTree>
+      <p:nvGrpSpPr>
+        <p:cNvPr id="1" name=""/>
+        <p:cNvGrpSpPr/>
+        <p:nvPr/>
+      </p:nvGrpSpPr>
+      <p:grpSpPr>
+        <a:xfrm>
+          <a:off x="0" y="0"/>
+          <a:ext cx="0" cy="0"/>
+          <a:chOff x="0" y="0"/>
+          <a:chExt cx="0" cy="0"/>
+        </a:xfrm>
+      </p:grpSpPr>
+      <p:sp>
+        <p:nvSpPr>
+          <p:cNvPr id="2" name="Slide Image Placeholder 1"/>
+          <p:cNvSpPr>
+            <a:spLocks noGrp="1"/>
+          </p:cNvSpPr>
+          <p:nvPr>
+            <p:ph type="sldImg" idx="2"/>
+          </p:nvPr>
+        </p:nvSpPr>
+        <p:spPr/>
+      </p:sp>
+      <p:sp>
+        <p:nvSpPr>
+          <p:cNvPr id="3" name="Notes Placeholder 2"/>
+          <p:cNvSpPr>
+            <a:spLocks noGrp="1"/>
+          </p:cNvSpPr>
+          <p:nvPr>
+            <p:ph type="body" idx="3" sz="quarter"/>
+          </p:nvPr>
+        </p:nvSpPr>
+        <p:spPr/>
+        <p:txBody>
+          <a:bodyPr/>
+          <a:lstStyle/>
+          <a:p>
+            <a:r>
+              <a:t>這是今天的核心投影片。讓我們總結 CSI 在哪裡消失。</a:t>
+            </a:r>
+          </a:p>
+          <a:p/>
+          <a:p>
+            <a:r>
+              <a:t>橙色和紅色標注的兩個元件是關鍵：OEM.sys 和 nwifi.sys。</a:t>
+            </a:r>
+          </a:p>
+          <a:p/>
+          <a:p>
+            <a:r>
+              <a:t>OEM.sys 有能力讀取 CSI（因為它可以直接訪問 NIC 硬體暫存器），但它不上報給 nwifi.sys。nwifi.sys 也從未向 OEM.sys 請求 CSI 資料。這個邊界就是 CSI 消失的地方。</a:t>
+            </a:r>
+          </a:p>
+          <a:p/>
+          <a:p>
+            <a:r>
+              <a:t>再往上，ndis.sys 沒有 CSI 的 OID 定義，tcpip.sys 只看到 IP 封包，應用程式完全感知不到 CSI 的存在。</a:t>
+            </a:r>
+          </a:p>
+          <a:p/>
+          <a:p>
+            <a:r>
+              <a:t>結論：CSI 的消失是多層架構決策累積的結果，每一層都有其合理性。</a:t>
+            </a:r>
+          </a:p>
+        </p:txBody>
+      </p:sp>
+      <p:sp>
+        <p:nvSpPr>
+          <p:cNvPr id="4" name="Slide Number Placeholder 3"/>
+          <p:cNvSpPr>
+            <a:spLocks noGrp="1"/>
+          </p:cNvSpPr>
+          <p:nvPr>
+            <p:ph type="sldNum" idx="5" sz="quarter"/>
+          </p:nvPr>
+        </p:nvSpPr>
+        <p:spPr/>
+      </p:sp>
+    </p:spTree>
+  </p:cSld>
+  <p:clrMapOvr>
+    <a:masterClrMapping/>
+  </p:clrMapOvr>
+</p:notes>
+</file>
+
+<file path=ppt/notesSlides/notesSlide15.xml><?xml version="1.0" encoding="utf-8"?>
+<p:notes xmlns:a="http://schemas.openxmlformats.org/drawingml/2006/main" xmlns:p="http://schemas.openxmlformats.org/presentationml/2006/main" xmlns:r="http://schemas.openxmlformats.org/officeDocument/2006/relationships">
+  <p:cSld>
+    <p:spTree>
+      <p:nvGrpSpPr>
+        <p:cNvPr id="1" name=""/>
+        <p:cNvGrpSpPr/>
+        <p:nvPr/>
+      </p:nvGrpSpPr>
+      <p:grpSpPr>
+        <a:xfrm>
+          <a:off x="0" y="0"/>
+          <a:ext cx="0" cy="0"/>
+          <a:chOff x="0" y="0"/>
+          <a:chExt cx="0" cy="0"/>
+        </a:xfrm>
+      </p:grpSpPr>
+      <p:sp>
+        <p:nvSpPr>
+          <p:cNvPr id="2" name="Slide Image Placeholder 1"/>
+          <p:cNvSpPr>
+            <a:spLocks noGrp="1"/>
+          </p:cNvSpPr>
+          <p:nvPr>
+            <p:ph type="sldImg" idx="2"/>
+          </p:nvPr>
+        </p:nvSpPr>
+        <p:spPr/>
+      </p:sp>
+      <p:sp>
+        <p:nvSpPr>
+          <p:cNvPr id="3" name="Notes Placeholder 2"/>
+          <p:cNvSpPr>
+            <a:spLocks noGrp="1"/>
+          </p:cNvSpPr>
+          <p:nvPr>
+            <p:ph type="body" idx="3" sz="quarter"/>
+          </p:nvPr>
+        </p:nvSpPr>
+        <p:spPr/>
+        <p:txBody>
+          <a:bodyPr/>
+          <a:lstStyle/>
+          <a:p>
+            <a:r>
+              <a:t>現在我們來看為什麼 Linux 可以取得 CSI。</a:t>
+            </a:r>
+          </a:p>
+          <a:p/>
+          <a:p>
+            <a:r>
+              <a:t>Linux 的關鍵優勢是開源。iwlwifi、ath9k、brcmfmac 這些驅動都是開源的，研究人員可以直接修改驅動程式碼，甚至修改 NIC 韌體。debugfs 提供了一個核心介面，讓驅動可以暴露任意的除錯資料，包括 CSI。</a:t>
+            </a:r>
+          </a:p>
+          <a:p/>
+          <a:p>
+            <a:r>
+              <a:t>右邊列出了 Windows 的根本差異：OEM.sys 是閉源二進位，不可修改；NDIS 介面固定，沒有擴充機制；韌體修改需要 WHQL 認證簽章。</a:t>
+            </a:r>
+          </a:p>
+          <a:p/>
+          <a:p>
+            <a:r>
+              <a:t>這不是 Windows 的 bug，而是商業產品（Windows）vs 開源生態（Linux）的架構哲學差異。</a:t>
+            </a:r>
+          </a:p>
+        </p:txBody>
+      </p:sp>
+      <p:sp>
+        <p:nvSpPr>
+          <p:cNvPr id="4" name="Slide Number Placeholder 3"/>
+          <p:cNvSpPr>
+            <a:spLocks noGrp="1"/>
+          </p:cNvSpPr>
+          <p:nvPr>
+            <p:ph type="sldNum" idx="5" sz="quarter"/>
+          </p:nvPr>
+        </p:nvSpPr>
+        <p:spPr/>
+      </p:sp>
+    </p:spTree>
+  </p:cSld>
+  <p:clrMapOvr>
+    <a:masterClrMapping/>
+  </p:clrMapOvr>
+</p:notes>
+</file>
+
+<file path=ppt/notesSlides/notesSlide16.xml><?xml version="1.0" encoding="utf-8"?>
+<p:notes xmlns:a="http://schemas.openxmlformats.org/drawingml/2006/main" xmlns:p="http://schemas.openxmlformats.org/presentationml/2006/main" xmlns:r="http://schemas.openxmlformats.org/officeDocument/2006/relationships">
+  <p:cSld>
+    <p:spTree>
+      <p:nvGrpSpPr>
+        <p:cNvPr id="1" name=""/>
+        <p:cNvGrpSpPr/>
+        <p:nvPr/>
+      </p:nvGrpSpPr>
+      <p:grpSpPr>
+        <a:xfrm>
+          <a:off x="0" y="0"/>
+          <a:ext cx="0" cy="0"/>
+          <a:chOff x="0" y="0"/>
+          <a:chExt cx="0" cy="0"/>
+        </a:xfrm>
+      </p:grpSpPr>
+      <p:sp>
+        <p:nvSpPr>
+          <p:cNvPr id="2" name="Slide Image Placeholder 1"/>
+          <p:cNvSpPr>
+            <a:spLocks noGrp="1"/>
+          </p:cNvSpPr>
+          <p:nvPr>
+            <p:ph type="sldImg" idx="2"/>
+          </p:nvPr>
+        </p:nvSpPr>
+        <p:spPr/>
+      </p:sp>
+      <p:sp>
+        <p:nvSpPr>
+          <p:cNvPr id="3" name="Notes Placeholder 2"/>
+          <p:cNvSpPr>
+            <a:spLocks noGrp="1"/>
+          </p:cNvSpPr>
+          <p:nvPr>
+            <p:ph type="body" idx="3" sz="quarter"/>
+          </p:nvPr>
+        </p:nvSpPr>
+        <p:spPr/>
+        <p:txBody>
+          <a:bodyPr/>
+          <a:lstStyle/>
+          <a:p>
+            <a:r>
+              <a:t>linux-80211n-csitool 是 2011 年由 Daniel Halperin 在華盛頓大學開發的，是學術界第一個廣泛使用的 CSI 工具。</a:t>
+            </a:r>
+          </a:p>
+          <a:p/>
+          <a:p>
+            <a:r>
+              <a:t>它的運作原理是：修改 Intel IWL5300 的韌體，讓它在每個接收到的 HT 封包後附加 CSI 矩陣。同時修改 iwlwifi 核心驅動，讓 CSI 資料可以傳到用戶空間。</a:t>
+            </a:r>
+          </a:p>
+          <a:p/>
+          <a:p>
+            <a:r>
+              <a:t>每個 CSI 矩陣是 [Ntx × Nrx × 30] 的複數陣列，30 個子載波群組，每個子載波 8-bit 複數。對 3x3 天線配置來說，每個封包有 9 個矩陣。</a:t>
+            </a:r>
+          </a:p>
+          <a:p/>
+          <a:p>
+            <a:r>
+              <a:t>這個工具非常有歷史意義，但它基於很舊的 Ubuntu 10.04 和 kernel 2.6.36，移植到現代系統需要額外工作。現在有更好的替代方案。</a:t>
+            </a:r>
+          </a:p>
+        </p:txBody>
+      </p:sp>
+      <p:sp>
+        <p:nvSpPr>
+          <p:cNvPr id="4" name="Slide Number Placeholder 3"/>
+          <p:cNvSpPr>
+            <a:spLocks noGrp="1"/>
+          </p:cNvSpPr>
+          <p:nvPr>
+            <p:ph type="sldNum" idx="5" sz="quarter"/>
+          </p:nvPr>
+        </p:nvSpPr>
+        <p:spPr/>
+      </p:sp>
+    </p:spTree>
+  </p:cSld>
+  <p:clrMapOvr>
+    <a:masterClrMapping/>
+  </p:clrMapOvr>
+</p:notes>
+</file>
+
+<file path=ppt/notesSlides/notesSlide17.xml><?xml version="1.0" encoding="utf-8"?>
+<p:notes xmlns:a="http://schemas.openxmlformats.org/drawingml/2006/main" xmlns:p="http://schemas.openxmlformats.org/presentationml/2006/main" xmlns:r="http://schemas.openxmlformats.org/officeDocument/2006/relationships">
+  <p:cSld>
+    <p:spTree>
+      <p:nvGrpSpPr>
+        <p:cNvPr id="1" name=""/>
+        <p:cNvGrpSpPr/>
+        <p:nvPr/>
+      </p:nvGrpSpPr>
+      <p:grpSpPr>
+        <a:xfrm>
+          <a:off x="0" y="0"/>
+          <a:ext cx="0" cy="0"/>
+          <a:chOff x="0" y="0"/>
+          <a:chExt cx="0" cy="0"/>
+        </a:xfrm>
+      </p:grpSpPr>
+      <p:sp>
+        <p:nvSpPr>
+          <p:cNvPr id="2" name="Slide Image Placeholder 1"/>
+          <p:cNvSpPr>
+            <a:spLocks noGrp="1"/>
+          </p:cNvSpPr>
+          <p:nvPr>
+            <p:ph type="sldImg" idx="2"/>
+          </p:nvPr>
+        </p:nvSpPr>
+        <p:spPr/>
+      </p:sp>
+      <p:sp>
+        <p:nvSpPr>
+          <p:cNvPr id="3" name="Notes Placeholder 2"/>
+          <p:cNvSpPr>
+            <a:spLocks noGrp="1"/>
+          </p:cNvSpPr>
+          <p:nvPr>
+            <p:ph type="body" idx="3" sz="quarter"/>
+          </p:nvPr>
+        </p:nvSpPr>
+        <p:spPr/>
+        <p:txBody>
+          <a:bodyPr/>
+          <a:lstStyle/>
+          <a:p>
+            <a:r>
+              <a:t>這是目前（2026 年）的現代 CSI 工具生態。</a:t>
+            </a:r>
+          </a:p>
+          <a:p/>
+          <a:p>
+            <a:r>
+              <a:t>PicoScenes 是目前功能最完整的平台，支援 Intel AX200/AX210，可以取得 802.11ax 格式的 CSI，最寬支援 160 MHz。它有商業支援，適合需要穩定維護的研究團隊。</a:t>
+            </a:r>
+          </a:p>
+          <a:p/>
+          <a:p>
+            <a:r>
+              <a:t>FeitCSI 是開源替代方案，功能相近，也支援 CSI 注入，可以用於主動量測。</a:t>
+            </a:r>
+          </a:p>
+          <a:p/>
+          <a:p>
+            <a:r>
+              <a:t>這張表的最右欄「平台」請注意：全部都是 Linux。這個事實本身就是今天演講的核心論點之一——所有成熟的 CSI 工具都選擇 Linux，因為 Windows 的架構限制讓這件事在 Windows 上無法實現。</a:t>
+            </a:r>
+          </a:p>
+        </p:txBody>
+      </p:sp>
+      <p:sp>
+        <p:nvSpPr>
+          <p:cNvPr id="4" name="Slide Number Placeholder 3"/>
+          <p:cNvSpPr>
+            <a:spLocks noGrp="1"/>
+          </p:cNvSpPr>
+          <p:nvPr>
+            <p:ph type="sldNum" idx="5" sz="quarter"/>
+          </p:nvPr>
+        </p:nvSpPr>
+        <p:spPr/>
+      </p:sp>
+    </p:spTree>
+  </p:cSld>
+  <p:clrMapOvr>
+    <a:masterClrMapping/>
+  </p:clrMapOvr>
+</p:notes>
+</file>
+
+<file path=ppt/notesSlides/notesSlide18.xml><?xml version="1.0" encoding="utf-8"?>
+<p:notes xmlns:a="http://schemas.openxmlformats.org/drawingml/2006/main" xmlns:p="http://schemas.openxmlformats.org/presentationml/2006/main" xmlns:r="http://schemas.openxmlformats.org/officeDocument/2006/relationships">
+  <p:cSld>
+    <p:spTree>
+      <p:nvGrpSpPr>
+        <p:cNvPr id="1" name=""/>
+        <p:cNvGrpSpPr/>
+        <p:nvPr/>
+      </p:nvGrpSpPr>
+      <p:grpSpPr>
+        <a:xfrm>
+          <a:off x="0" y="0"/>
+          <a:ext cx="0" cy="0"/>
+          <a:chOff x="0" y="0"/>
+          <a:chExt cx="0" cy="0"/>
+        </a:xfrm>
+      </p:grpSpPr>
+      <p:sp>
+        <p:nvSpPr>
+          <p:cNvPr id="2" name="Slide Image Placeholder 1"/>
+          <p:cNvSpPr>
+            <a:spLocks noGrp="1"/>
+          </p:cNvSpPr>
+          <p:nvPr>
+            <p:ph type="sldImg" idx="2"/>
+          </p:nvPr>
+        </p:nvSpPr>
+        <p:spPr/>
+      </p:sp>
+      <p:sp>
+        <p:nvSpPr>
+          <p:cNvPr id="3" name="Notes Placeholder 2"/>
+          <p:cNvSpPr>
+            <a:spLocks noGrp="1"/>
+          </p:cNvSpPr>
+          <p:nvPr>
+            <p:ph type="body" idx="3" sz="quarter"/>
+          </p:nvPr>
+        </p:nvSpPr>
+        <p:spPr/>
+        <p:txBody>
+          <a:bodyPr/>
+          <a:lstStyle/>
+          <a:p>
+            <a:r>
+              <a:t>第一個 Windows 替代方案是 raw packet capture，使用 WinPcap 或 Npcap。</a:t>
+            </a:r>
+          </a:p>
+          <a:p/>
+          <a:p>
+            <a:r>
+              <a:t>如果你的網卡支援 Monitor Mode（不是所有 Windows 網卡都支援），你可以用 Wireshark 或類似工具捕獲 802.11 frame。Radiotap header 會包含一些 PHY 資訊，包括 RSSI、資料速率、頻道等。</a:t>
+            </a:r>
+          </a:p>
+          <a:p/>
+          <a:p>
+            <a:r>
+              <a:t>但是——沒有 CSI。Radiotap header 的設計裡根本沒有 CSI 欄位的定義。你拿到的是 frame level 的資訊，不是 subcarrier level 的通道資訊。</a:t>
+            </a:r>
+          </a:p>
+          <a:p/>
+          <a:p>
+            <a:r>
+              <a:t>這個方案適合封包分析和基本的 RF 環境監控，但不能取代 CSI。</a:t>
+            </a:r>
+          </a:p>
+        </p:txBody>
+      </p:sp>
+      <p:sp>
+        <p:nvSpPr>
+          <p:cNvPr id="4" name="Slide Number Placeholder 3"/>
+          <p:cNvSpPr>
+            <a:spLocks noGrp="1"/>
+          </p:cNvSpPr>
+          <p:nvPr>
+            <p:ph type="sldNum" idx="5" sz="quarter"/>
+          </p:nvPr>
+        </p:nvSpPr>
+        <p:spPr/>
+      </p:sp>
+    </p:spTree>
+  </p:cSld>
+  <p:clrMapOvr>
+    <a:masterClrMapping/>
+  </p:clrMapOvr>
+</p:notes>
+</file>
+
+<file path=ppt/notesSlides/notesSlide19.xml><?xml version="1.0" encoding="utf-8"?>
+<p:notes xmlns:a="http://schemas.openxmlformats.org/drawingml/2006/main" xmlns:p="http://schemas.openxmlformats.org/presentationml/2006/main" xmlns:r="http://schemas.openxmlformats.org/officeDocument/2006/relationships">
+  <p:cSld>
+    <p:spTree>
+      <p:nvGrpSpPr>
+        <p:cNvPr id="1" name=""/>
+        <p:cNvGrpSpPr/>
+        <p:nvPr/>
+      </p:nvGrpSpPr>
+      <p:grpSpPr>
+        <a:xfrm>
+          <a:off x="0" y="0"/>
+          <a:ext cx="0" cy="0"/>
+          <a:chOff x="0" y="0"/>
+          <a:chExt cx="0" cy="0"/>
+        </a:xfrm>
+      </p:grpSpPr>
+      <p:sp>
+        <p:nvSpPr>
+          <p:cNvPr id="2" name="Slide Image Placeholder 1"/>
+          <p:cNvSpPr>
+            <a:spLocks noGrp="1"/>
+          </p:cNvSpPr>
+          <p:nvPr>
+            <p:ph type="sldImg" idx="2"/>
+          </p:nvPr>
+        </p:nvSpPr>
+        <p:spPr/>
+      </p:sp>
+      <p:sp>
+        <p:nvSpPr>
+          <p:cNvPr id="3" name="Notes Placeholder 2"/>
+          <p:cNvSpPr>
+            <a:spLocks noGrp="1"/>
+          </p:cNvSpPr>
+          <p:nvPr>
+            <p:ph type="body" idx="3" sz="quarter"/>
+          </p:nvPr>
+        </p:nvSpPr>
+        <p:spPr/>
+        <p:txBody>
+          <a:bodyPr/>
+          <a:lstStyle/>
+          <a:p>
+            <a:r>
+              <a:t>第二個方案是透過 OEM 私有 IOCTL 介面。這是最接近在 Windows 上取得 CSI 的方式，但也是風險最高的。</a:t>
+            </a:r>
+          </a:p>
+          <a:p/>
+          <a:p>
+            <a:r>
+              <a:t>你需要用 IDA Pro 或 Ghidra 逆向 OEM.sys，找到可能處理 CSI 的 IOCTL dispatch 函式，確認輸入輸出格式，然後寫程式呼叫它。Intel 的 netwtw*.sys 在某些版本有私有介面，但完全沒有公開文件。</a:t>
+            </a:r>
+          </a:p>
+          <a:p/>
+          <a:p>
+            <a:r>
+              <a:t>實際問題是：每次 Windows Update 或驅動更新，IOCTL code 可能改變，你的程式就壞了。另外，呼叫未簽章的驅動介面可能觸發 Secure Boot 的驗證機制。</a:t>
+            </a:r>
+          </a:p>
+          <a:p/>
+          <a:p>
+            <a:r>
+              <a:t>這個方案我不建議用在任何需要長期維護的系統上。</a:t>
+            </a:r>
+          </a:p>
+        </p:txBody>
+      </p:sp>
+      <p:sp>
+        <p:nvSpPr>
+          <p:cNvPr id="4" name="Slide Number Placeholder 3"/>
+          <p:cNvSpPr>
+            <a:spLocks noGrp="1"/>
+          </p:cNvSpPr>
+          <p:nvPr>
+            <p:ph type="sldNum" idx="5" sz="quarter"/>
+          </p:nvPr>
+        </p:nvSpPr>
+        <p:spPr/>
+      </p:sp>
+    </p:spTree>
+  </p:cSld>
+  <p:clrMapOvr>
+    <a:masterClrMapping/>
+  </p:clrMapOvr>
+</p:notes>
+</file>
+
+<file path=ppt/notesSlides/notesSlide2.xml><?xml version="1.0" encoding="utf-8"?>
+<p:notes xmlns:a="http://schemas.openxmlformats.org/drawingml/2006/main" xmlns:p="http://schemas.openxmlformats.org/presentationml/2006/main" xmlns:r="http://schemas.openxmlformats.org/officeDocument/2006/relationships">
+  <p:cSld>
+    <p:spTree>
+      <p:nvGrpSpPr>
+        <p:cNvPr id="1" name=""/>
+        <p:cNvGrpSpPr/>
+        <p:nvPr/>
+      </p:nvGrpSpPr>
+      <p:grpSpPr>
+        <a:xfrm>
+          <a:off x="0" y="0"/>
+          <a:ext cx="0" cy="0"/>
+          <a:chOff x="0" y="0"/>
+          <a:chExt cx="0" cy="0"/>
+        </a:xfrm>
+      </p:grpSpPr>
+      <p:sp>
+        <p:nvSpPr>
+          <p:cNvPr id="2" name="Slide Image Placeholder 1"/>
+          <p:cNvSpPr>
+            <a:spLocks noGrp="1"/>
+          </p:cNvSpPr>
+          <p:nvPr>
+            <p:ph type="sldImg" idx="2"/>
+          </p:nvPr>
+        </p:nvSpPr>
+        <p:spPr/>
+      </p:sp>
+      <p:sp>
+        <p:nvSpPr>
+          <p:cNvPr id="3" name="Notes Placeholder 2"/>
+          <p:cNvSpPr>
+            <a:spLocks noGrp="1"/>
+          </p:cNvSpPr>
+          <p:nvPr>
+            <p:ph type="body" idx="3" sz="quarter"/>
+          </p:nvPr>
+        </p:nvSpPr>
+        <p:spPr/>
+        <p:txBody>
+          <a:bodyPr/>
+          <a:lstStyle/>
+          <a:p>
+            <a:r>
+              <a:t>今天的內容分四段。</a:t>
+            </a:r>
+          </a:p>
+          <a:p/>
+          <a:p>
+            <a:r>
+              <a:t>第一段從 PHY/MAC 基礎出發，確保大家對 CSI 的定義有共同的認知。第二段進入 Windows 的驅動架構，這是大多數 RF 工程師比較陌生的領域。第三段是今天的核心：為什麼 Linux 可以但 Windows 不行，以及有哪些替代方案。最後給出實際的硬體選型建議。</a:t>
+            </a:r>
+          </a:p>
+          <a:p/>
+          <a:p>
+            <a:r>
+              <a:t>整個演講大約 45 到 60 分鐘，最後留時間 Q&amp;A。</a:t>
+            </a:r>
+          </a:p>
+        </p:txBody>
+      </p:sp>
+      <p:sp>
+        <p:nvSpPr>
+          <p:cNvPr id="4" name="Slide Number Placeholder 3"/>
+          <p:cNvSpPr>
+            <a:spLocks noGrp="1"/>
+          </p:cNvSpPr>
+          <p:nvPr>
+            <p:ph type="sldNum" idx="5" sz="quarter"/>
+          </p:nvPr>
+        </p:nvSpPr>
+        <p:spPr/>
+      </p:sp>
+    </p:spTree>
+  </p:cSld>
+  <p:clrMapOvr>
+    <a:masterClrMapping/>
+  </p:clrMapOvr>
+</p:notes>
+</file>
+
+<file path=ppt/notesSlides/notesSlide20.xml><?xml version="1.0" encoding="utf-8"?>
+<p:notes xmlns:a="http://schemas.openxmlformats.org/drawingml/2006/main" xmlns:p="http://schemas.openxmlformats.org/presentationml/2006/main" xmlns:r="http://schemas.openxmlformats.org/officeDocument/2006/relationships">
+  <p:cSld>
+    <p:spTree>
+      <p:nvGrpSpPr>
+        <p:cNvPr id="1" name=""/>
+        <p:cNvGrpSpPr/>
+        <p:nvPr/>
+      </p:nvGrpSpPr>
+      <p:grpSpPr>
+        <a:xfrm>
+          <a:off x="0" y="0"/>
+          <a:ext cx="0" cy="0"/>
+          <a:chOff x="0" y="0"/>
+          <a:chExt cx="0" cy="0"/>
+        </a:xfrm>
+      </p:grpSpPr>
+      <p:sp>
+        <p:nvSpPr>
+          <p:cNvPr id="2" name="Slide Image Placeholder 1"/>
+          <p:cNvSpPr>
+            <a:spLocks noGrp="1"/>
+          </p:cNvSpPr>
+          <p:nvPr>
+            <p:ph type="sldImg" idx="2"/>
+          </p:nvPr>
+        </p:nvSpPr>
+        <p:spPr/>
+      </p:sp>
+      <p:sp>
+        <p:nvSpPr>
+          <p:cNvPr id="3" name="Notes Placeholder 2"/>
+          <p:cNvSpPr>
+            <a:spLocks noGrp="1"/>
+          </p:cNvSpPr>
+          <p:nvPr>
+            <p:ph type="body" idx="3" sz="quarter"/>
+          </p:nvPr>
+        </p:nvSpPr>
+        <p:spPr/>
+        <p:txBody>
+          <a:bodyPr/>
+          <a:lstStyle/>
+          <a:p>
+            <a:r>
+              <a:t>第三個方案是最實際的工程折衷：雙系統。</a:t>
+            </a:r>
+          </a:p>
+          <a:p/>
+          <a:p>
+            <a:r>
+              <a:t>推薦架構是在同一台機器上安裝 Linux 和 Windows，用 Linux 取 CSI，用 Windows 做後處理。這樣可以充分利用兩個 OS 的優勢：Linux 的 CSI 工具生態 + Windows 的 MATLAB 或其他分析工具。</a:t>
+            </a:r>
+          </a:p>
+          <a:p/>
+          <a:p>
+            <a:r>
+              <a:t>FeitCSI 提供 Live USB 映像，如果你不想安裝 Linux，可以用 USB 開機進 Linux 取資料，完成後重開機回 Windows。</a:t>
+            </a:r>
+          </a:p>
+          <a:p/>
+          <a:p>
+            <a:r>
+              <a:t>VM 方案通常不可行，因為 PCIe 網卡無法直通給 VM，而 USB WiFi 網卡的時序精度在 Hypervisor 下會受影響。</a:t>
+            </a:r>
+          </a:p>
+          <a:p/>
+          <a:p>
+            <a:r>
+              <a:t>結論：雙系統是 RF 工程師最省力的 CSI 採集方案。</a:t>
+            </a:r>
+          </a:p>
+        </p:txBody>
+      </p:sp>
+      <p:sp>
+        <p:nvSpPr>
+          <p:cNvPr id="4" name="Slide Number Placeholder 3"/>
+          <p:cNvSpPr>
+            <a:spLocks noGrp="1"/>
+          </p:cNvSpPr>
+          <p:nvPr>
+            <p:ph type="sldNum" idx="5" sz="quarter"/>
+          </p:nvPr>
+        </p:nvSpPr>
+        <p:spPr/>
+      </p:sp>
+    </p:spTree>
+  </p:cSld>
+  <p:clrMapOvr>
+    <a:masterClrMapping/>
+  </p:clrMapOvr>
+</p:notes>
+</file>
+
+<file path=ppt/notesSlides/notesSlide21.xml><?xml version="1.0" encoding="utf-8"?>
+<p:notes xmlns:a="http://schemas.openxmlformats.org/drawingml/2006/main" xmlns:p="http://schemas.openxmlformats.org/presentationml/2006/main" xmlns:r="http://schemas.openxmlformats.org/officeDocument/2006/relationships">
+  <p:cSld>
+    <p:spTree>
+      <p:nvGrpSpPr>
+        <p:cNvPr id="1" name=""/>
+        <p:cNvGrpSpPr/>
+        <p:nvPr/>
+      </p:nvGrpSpPr>
+      <p:grpSpPr>
+        <a:xfrm>
+          <a:off x="0" y="0"/>
+          <a:ext cx="0" cy="0"/>
+          <a:chOff x="0" y="0"/>
+          <a:chExt cx="0" cy="0"/>
+        </a:xfrm>
+      </p:grpSpPr>
+      <p:sp>
+        <p:nvSpPr>
+          <p:cNvPr id="2" name="Slide Image Placeholder 1"/>
+          <p:cNvSpPr>
+            <a:spLocks noGrp="1"/>
+          </p:cNvSpPr>
+          <p:nvPr>
+            <p:ph type="sldImg" idx="2"/>
+          </p:nvPr>
+        </p:nvSpPr>
+        <p:spPr/>
+      </p:sp>
+      <p:sp>
+        <p:nvSpPr>
+          <p:cNvPr id="3" name="Notes Placeholder 2"/>
+          <p:cNvSpPr>
+            <a:spLocks noGrp="1"/>
+          </p:cNvSpPr>
+          <p:nvPr>
+            <p:ph type="body" idx="3" sz="quarter"/>
+          </p:nvPr>
+        </p:nvSpPr>
+        <p:spPr/>
+        <p:txBody>
+          <a:bodyPr/>
+          <a:lstStyle/>
+          <a:p>
+            <a:r>
+              <a:t>這張表快速比較五種方案。</a:t>
+            </a:r>
+          </a:p>
+          <a:p/>
+          <a:p>
+            <a:r>
+              <a:t>難度最低的兩個是 Raw Packet Capture 和 Linux Live USB，但前者根本取不到 CSI。Linux Live USB 是最簡單且可以取到完整 CSI 的方案。</a:t>
+            </a:r>
+          </a:p>
+          <a:p/>
+          <a:p>
+            <a:r>
+              <a:t>雙系統稍微複雜一點，但提供最穩定的長期使用體驗，維護成本也很低。</a:t>
+            </a:r>
+          </a:p>
+          <a:p/>
+          <a:p>
+            <a:r>
+              <a:t>OEM 私有 IOCTL 是唯一可以在 Windows 原生環境取 CSI 的方案，但維護成本極高，我在這裡標注為「極高」是認真的——你需要對每個新版本的驅動都重新逆向。</a:t>
+            </a:r>
+          </a:p>
+          <a:p/>
+          <a:p>
+            <a:r>
+              <a:t>建議：除非有非常強烈的理由必須在 Windows 原生環境取 CSI，否則雙系統就是標準答案。</a:t>
+            </a:r>
+          </a:p>
+        </p:txBody>
+      </p:sp>
+      <p:sp>
+        <p:nvSpPr>
+          <p:cNvPr id="4" name="Slide Number Placeholder 3"/>
+          <p:cNvSpPr>
+            <a:spLocks noGrp="1"/>
+          </p:cNvSpPr>
+          <p:nvPr>
+            <p:ph type="sldNum" idx="5" sz="quarter"/>
+          </p:nvPr>
+        </p:nvSpPr>
+        <p:spPr/>
+      </p:sp>
+    </p:spTree>
+  </p:cSld>
+  <p:clrMapOvr>
+    <a:masterClrMapping/>
+  </p:clrMapOvr>
+</p:notes>
+</file>
+
+<file path=ppt/notesSlides/notesSlide22.xml><?xml version="1.0" encoding="utf-8"?>
+<p:notes xmlns:a="http://schemas.openxmlformats.org/drawingml/2006/main" xmlns:p="http://schemas.openxmlformats.org/presentationml/2006/main" xmlns:r="http://schemas.openxmlformats.org/officeDocument/2006/relationships">
+  <p:cSld>
+    <p:spTree>
+      <p:nvGrpSpPr>
+        <p:cNvPr id="1" name=""/>
+        <p:cNvGrpSpPr/>
+        <p:nvPr/>
+      </p:nvGrpSpPr>
+      <p:grpSpPr>
+        <a:xfrm>
+          <a:off x="0" y="0"/>
+          <a:ext cx="0" cy="0"/>
+          <a:chOff x="0" y="0"/>
+          <a:chExt cx="0" cy="0"/>
+        </a:xfrm>
+      </p:grpSpPr>
+      <p:sp>
+        <p:nvSpPr>
+          <p:cNvPr id="2" name="Slide Image Placeholder 1"/>
+          <p:cNvSpPr>
+            <a:spLocks noGrp="1"/>
+          </p:cNvSpPr>
+          <p:nvPr>
+            <p:ph type="sldImg" idx="2"/>
+          </p:nvPr>
+        </p:nvSpPr>
+        <p:spPr/>
+      </p:sp>
+      <p:sp>
+        <p:nvSpPr>
+          <p:cNvPr id="3" name="Notes Placeholder 2"/>
+          <p:cNvSpPr>
+            <a:spLocks noGrp="1"/>
+          </p:cNvSpPr>
+          <p:nvPr>
+            <p:ph type="body" idx="3" sz="quarter"/>
+          </p:nvPr>
+        </p:nvSpPr>
+        <p:spPr/>
+        <p:txBody>
+          <a:bodyPr/>
+          <a:lstStyle/>
+          <a:p>
+            <a:r>
+              <a:t>這張表列出目前（2026 年）有明確 CSI 工具支援的網卡。</a:t>
+            </a:r>
+          </a:p>
+          <a:p/>
+          <a:p>
+            <a:r>
+              <a:t>如果你要買新硬體，Intel AX200 M.2 是最容易取得、工具支援最完整的選擇。它便宜（通常 500 到 1000 台幣），支援 802.11ax，PicoScenes 和 FeitCSI 都支援它。買 M.2 版本可以裝在筆電或桌機，或者用 M.2 轉 PCIe 轉接卡。</a:t>
+            </a:r>
+          </a:p>
+          <a:p/>
+          <a:p>
+            <a:r>
+              <a:t>如果你有 Raspberry Pi，BCM43455 晶片已經內建，Nexmon CSI 直接支援，不需要額外購買硬體，非常適合做嵌入式 CSI 採集節點。</a:t>
+            </a:r>
+          </a:p>
+          <a:p/>
+          <a:p>
+            <a:r>
+              <a:t>Atheros AR9380 在 OpenWRT 路由器上很常見，適合布署多點 CSI 量測環境。</a:t>
+            </a:r>
+          </a:p>
+          <a:p/>
+          <a:p>
+            <a:r>
+              <a:t>請避免購買沒有在這份清單上的網卡，除非你願意自己移植驅動。</a:t>
+            </a:r>
+          </a:p>
+        </p:txBody>
+      </p:sp>
+      <p:sp>
+        <p:nvSpPr>
+          <p:cNvPr id="4" name="Slide Number Placeholder 3"/>
+          <p:cNvSpPr>
+            <a:spLocks noGrp="1"/>
+          </p:cNvSpPr>
+          <p:nvPr>
+            <p:ph type="sldNum" idx="5" sz="quarter"/>
+          </p:nvPr>
+        </p:nvSpPr>
+        <p:spPr/>
+      </p:sp>
+    </p:spTree>
+  </p:cSld>
+  <p:clrMapOvr>
+    <a:masterClrMapping/>
+  </p:clrMapOvr>
+</p:notes>
+</file>
+
+<file path=ppt/notesSlides/notesSlide23.xml><?xml version="1.0" encoding="utf-8"?>
+<p:notes xmlns:a="http://schemas.openxmlformats.org/drawingml/2006/main" xmlns:p="http://schemas.openxmlformats.org/presentationml/2006/main" xmlns:r="http://schemas.openxmlformats.org/officeDocument/2006/relationships">
+  <p:cSld>
+    <p:spTree>
+      <p:nvGrpSpPr>
+        <p:cNvPr id="1" name=""/>
+        <p:cNvGrpSpPr/>
+        <p:nvPr/>
+      </p:nvGrpSpPr>
+      <p:grpSpPr>
+        <a:xfrm>
+          <a:off x="0" y="0"/>
+          <a:ext cx="0" cy="0"/>
+          <a:chOff x="0" y="0"/>
+          <a:chExt cx="0" cy="0"/>
+        </a:xfrm>
+      </p:grpSpPr>
+      <p:sp>
+        <p:nvSpPr>
+          <p:cNvPr id="2" name="Slide Image Placeholder 1"/>
+          <p:cNvSpPr>
+            <a:spLocks noGrp="1"/>
+          </p:cNvSpPr>
+          <p:nvPr>
+            <p:ph type="sldImg" idx="2"/>
+          </p:nvPr>
+        </p:nvSpPr>
+        <p:spPr/>
+      </p:sp>
+      <p:sp>
+        <p:nvSpPr>
+          <p:cNvPr id="3" name="Notes Placeholder 2"/>
+          <p:cNvSpPr>
+            <a:spLocks noGrp="1"/>
+          </p:cNvSpPr>
+          <p:nvPr>
+            <p:ph type="body" idx="3" sz="quarter"/>
+          </p:nvPr>
+        </p:nvSpPr>
+        <p:spPr/>
+        <p:txBody>
+          <a:bodyPr/>
+          <a:lstStyle/>
+          <a:p>
+            <a:r>
+              <a:t>讓我們用這張總結圖回顧整個旅程。</a:t>
+            </a:r>
+          </a:p>
+          <a:p/>
+          <a:p>
+            <a:r>
+              <a:t>從最下面的 PHY 硬體開始，OFDM 解調計算出 CSI，儲存在 NIC 韌體的暫存器中。NIC 韌體計算完成後，這個資訊就在這裡等待被讀取。</a:t>
+            </a:r>
+          </a:p>
+          <a:p/>
+          <a:p>
+            <a:r>
+              <a:t>OEM.sys 是唯一有能力讀取這個資料的軟體元件，但它的設計目標不包含上報 CSI，所以它沒有這樣做。</a:t>
+            </a:r>
+          </a:p>
+          <a:p/>
+          <a:p>
+            <a:r>
+              <a:t>往上的每一層，從 nwifi.sys 到 NDIS 到應用程式，都沒有任何機制可以取得 CSI。每一層都有合理的設計動機，但合在一起的結果就是 CSI 無法從應用層存取。</a:t>
+            </a:r>
+          </a:p>
+          <a:p/>
+          <a:p>
+            <a:r>
+              <a:t>這不是一個單一決策造成的問題，而是多層架構設計累積的結果。</a:t>
+            </a:r>
+          </a:p>
+        </p:txBody>
+      </p:sp>
+      <p:sp>
+        <p:nvSpPr>
+          <p:cNvPr id="4" name="Slide Number Placeholder 3"/>
+          <p:cNvSpPr>
+            <a:spLocks noGrp="1"/>
+          </p:cNvSpPr>
+          <p:nvPr>
+            <p:ph type="sldNum" idx="5" sz="quarter"/>
+          </p:nvPr>
+        </p:nvSpPr>
+        <p:spPr/>
+      </p:sp>
+    </p:spTree>
+  </p:cSld>
+  <p:clrMapOvr>
+    <a:masterClrMapping/>
+  </p:clrMapOvr>
+</p:notes>
+</file>
+
+<file path=ppt/notesSlides/notesSlide24.xml><?xml version="1.0" encoding="utf-8"?>
+<p:notes xmlns:a="http://schemas.openxmlformats.org/drawingml/2006/main" xmlns:p="http://schemas.openxmlformats.org/presentationml/2006/main" xmlns:r="http://schemas.openxmlformats.org/officeDocument/2006/relationships">
+  <p:cSld>
+    <p:spTree>
+      <p:nvGrpSpPr>
+        <p:cNvPr id="1" name=""/>
+        <p:cNvGrpSpPr/>
+        <p:nvPr/>
+      </p:nvGrpSpPr>
+      <p:grpSpPr>
+        <a:xfrm>
+          <a:off x="0" y="0"/>
+          <a:ext cx="0" cy="0"/>
+          <a:chOff x="0" y="0"/>
+          <a:chExt cx="0" cy="0"/>
+        </a:xfrm>
+      </p:grpSpPr>
+      <p:sp>
+        <p:nvSpPr>
+          <p:cNvPr id="2" name="Slide Image Placeholder 1"/>
+          <p:cNvSpPr>
+            <a:spLocks noGrp="1"/>
+          </p:cNvSpPr>
+          <p:nvPr>
+            <p:ph type="sldImg" idx="2"/>
+          </p:nvPr>
+        </p:nvSpPr>
+        <p:spPr/>
+      </p:sp>
+      <p:sp>
+        <p:nvSpPr>
+          <p:cNvPr id="3" name="Notes Placeholder 2"/>
+          <p:cNvSpPr>
+            <a:spLocks noGrp="1"/>
+          </p:cNvSpPr>
+          <p:nvPr>
+            <p:ph type="body" idx="3" sz="quarter"/>
+          </p:nvPr>
+        </p:nvSpPr>
+        <p:spPr/>
+        <p:txBody>
+          <a:bodyPr/>
+          <a:lstStyle/>
+          <a:p>
+            <a:r>
+              <a:t>基於今天的所有內容，給各位幾個具體建議。</a:t>
+            </a:r>
+          </a:p>
+          <a:p/>
+          <a:p>
+            <a:r>
+              <a:t>第一，買硬體前先確認 CSI 工具支援。不要買了才發現沒有工具可以用，Intel AX200/AX210 目前是最安全的選擇。</a:t>
+            </a:r>
+          </a:p>
+          <a:p/>
+          <a:p>
+            <a:r>
+              <a:t>第二，用 Linux 取 CSI，PicoScenes 或 FeitCSI 是推薦的工具。雙系統是最穩定的部署方式。</a:t>
+            </a:r>
+          </a:p>
+          <a:p/>
+          <a:p>
+            <a:r>
+              <a:t>第三，Windows 用來做後處理。你的 MATLAB 腳本、Python 分析程式、可視化工具都可以在 Windows 上跑，只要在 Linux 上把 CSI 資料存成通用格式（.mat 或 .csv）就可以了。</a:t>
+            </a:r>
+          </a:p>
+          <a:p/>
+          <a:p>
+            <a:r>
+              <a:t>第四，三個要避免的坑：不要依賴 OEM 私有 IOCTL、不要用 VM 取 CSI、不要買沒有工具支援的網卡。</a:t>
+            </a:r>
+          </a:p>
+          <a:p/>
+          <a:p>
+            <a:r>
+              <a:t>今天的演講希望幫助各位在投入 CSI 研究前，對整個架構有清楚的認識，避免走彎路。</a:t>
+            </a:r>
+          </a:p>
+        </p:txBody>
+      </p:sp>
+      <p:sp>
+        <p:nvSpPr>
+          <p:cNvPr id="4" name="Slide Number Placeholder 3"/>
+          <p:cNvSpPr>
+            <a:spLocks noGrp="1"/>
+          </p:cNvSpPr>
+          <p:nvPr>
+            <p:ph type="sldNum" idx="5" sz="quarter"/>
+          </p:nvPr>
+        </p:nvSpPr>
+        <p:spPr/>
+      </p:sp>
+    </p:spTree>
+  </p:cSld>
+  <p:clrMapOvr>
+    <a:masterClrMapping/>
+  </p:clrMapOvr>
+</p:notes>
+</file>
+
+<file path=ppt/notesSlides/notesSlide25.xml><?xml version="1.0" encoding="utf-8"?>
+<p:notes xmlns:a="http://schemas.openxmlformats.org/drawingml/2006/main" xmlns:p="http://schemas.openxmlformats.org/presentationml/2006/main" xmlns:r="http://schemas.openxmlformats.org/officeDocument/2006/relationships">
+  <p:cSld>
+    <p:spTree>
+      <p:nvGrpSpPr>
+        <p:cNvPr id="1" name=""/>
+        <p:cNvGrpSpPr/>
+        <p:nvPr/>
+      </p:nvGrpSpPr>
+      <p:grpSpPr>
+        <a:xfrm>
+          <a:off x="0" y="0"/>
+          <a:ext cx="0" cy="0"/>
+          <a:chOff x="0" y="0"/>
+          <a:chExt cx="0" cy="0"/>
+        </a:xfrm>
+      </p:grpSpPr>
+      <p:sp>
+        <p:nvSpPr>
+          <p:cNvPr id="2" name="Slide Image Placeholder 1"/>
+          <p:cNvSpPr>
+            <a:spLocks noGrp="1"/>
+          </p:cNvSpPr>
+          <p:nvPr>
+            <p:ph type="sldImg" idx="2"/>
+          </p:nvPr>
+        </p:nvSpPr>
+        <p:spPr/>
+      </p:sp>
+      <p:sp>
+        <p:nvSpPr>
+          <p:cNvPr id="3" name="Notes Placeholder 2"/>
+          <p:cNvSpPr>
+            <a:spLocks noGrp="1"/>
+          </p:cNvSpPr>
+          <p:nvPr>
+            <p:ph type="body" idx="3" sz="quarter"/>
+          </p:nvPr>
+        </p:nvSpPr>
+        <p:spPr/>
+        <p:txBody>
+          <a:bodyPr/>
+          <a:lstStyle/>
+          <a:p>
+            <a:r>
+              <a:t>以上是今天的所有內容。</a:t>
+            </a:r>
+          </a:p>
+          <a:p/>
+          <a:p>
+            <a:r>
+              <a:t>如果你要開始 CSI 研究，推薦先看 PicoScenes 的文件（ps.zpj.io），它提供了很完整的 setup guide。FeitCSI（feitcsi.kuskosoft.com）是開源替代方案，適合想要自己修改的研究者。CSIKit 是一個 Python 函式庫，可以解析多種 CSI 工具的輸出格式，方便資料分析。</a:t>
+            </a:r>
+          </a:p>
+          <a:p/>
+          <a:p>
+            <a:r>
+              <a:t>有任何問題嗎？</a:t>
+            </a:r>
+          </a:p>
+        </p:txBody>
+      </p:sp>
+      <p:sp>
+        <p:nvSpPr>
+          <p:cNvPr id="4" name="Slide Number Placeholder 3"/>
+          <p:cNvSpPr>
+            <a:spLocks noGrp="1"/>
+          </p:cNvSpPr>
+          <p:nvPr>
+            <p:ph type="sldNum" idx="5" sz="quarter"/>
+          </p:nvPr>
+        </p:nvSpPr>
+        <p:spPr/>
+      </p:sp>
+    </p:spTree>
+  </p:cSld>
+  <p:clrMapOvr>
+    <a:masterClrMapping/>
+  </p:clrMapOvr>
+</p:notes>
+</file>
+
+<file path=ppt/notesSlides/notesSlide3.xml><?xml version="1.0" encoding="utf-8"?>
+<p:notes xmlns:a="http://schemas.openxmlformats.org/drawingml/2006/main" xmlns:p="http://schemas.openxmlformats.org/presentationml/2006/main" xmlns:r="http://schemas.openxmlformats.org/officeDocument/2006/relationships">
+  <p:cSld>
+    <p:spTree>
+      <p:nvGrpSpPr>
+        <p:cNvPr id="1" name=""/>
+        <p:cNvGrpSpPr/>
+        <p:nvPr/>
+      </p:nvGrpSpPr>
+      <p:grpSpPr>
+        <a:xfrm>
+          <a:off x="0" y="0"/>
+          <a:ext cx="0" cy="0"/>
+          <a:chOff x="0" y="0"/>
+          <a:chExt cx="0" cy="0"/>
+        </a:xfrm>
+      </p:grpSpPr>
+      <p:sp>
+        <p:nvSpPr>
+          <p:cNvPr id="2" name="Slide Image Placeholder 1"/>
+          <p:cNvSpPr>
+            <a:spLocks noGrp="1"/>
+          </p:cNvSpPr>
+          <p:nvPr>
+            <p:ph type="sldImg" idx="2"/>
+          </p:nvPr>
+        </p:nvSpPr>
+        <p:spPr/>
+      </p:sp>
+      <p:sp>
+        <p:nvSpPr>
+          <p:cNvPr id="3" name="Notes Placeholder 2"/>
+          <p:cNvSpPr>
+            <a:spLocks noGrp="1"/>
+          </p:cNvSpPr>
+          <p:nvPr>
+            <p:ph type="body" idx="3" sz="quarter"/>
+          </p:nvPr>
+        </p:nvSpPr>
+        <p:spPr/>
+        <p:txBody>
+          <a:bodyPr/>
+          <a:lstStyle/>
+          <a:p>
+            <a:r>
+              <a:t>這張圖應該是大家最熟悉的起點。從天線接收到 RF 信號後，經過 ADC 轉換成數位信號，再透過 OFDM 解調把各個子載波分離出來，最後解碼成 802.11 frame。</a:t>
+            </a:r>
+          </a:p>
+          <a:p/>
+          <a:p>
+            <a:r>
+              <a:t>關鍵點在這裡：CSI 的計算發生在 OFDM 解調這個步驟。每個子載波在解調過程中，NIC 的 DSP 會計算出複數增益，這就是 CSI 的來源。這個資料此時還在 NIC 的韌體裡，尚未進入任何 OS 軟體層。</a:t>
+            </a:r>
+          </a:p>
+        </p:txBody>
+      </p:sp>
+      <p:sp>
+        <p:nvSpPr>
+          <p:cNvPr id="4" name="Slide Number Placeholder 3"/>
+          <p:cNvSpPr>
+            <a:spLocks noGrp="1"/>
+          </p:cNvSpPr>
+          <p:nvPr>
+            <p:ph type="sldNum" idx="5" sz="quarter"/>
+          </p:nvPr>
+        </p:nvSpPr>
+        <p:spPr/>
+      </p:sp>
+    </p:spTree>
+  </p:cSld>
+  <p:clrMapOvr>
+    <a:masterClrMapping/>
+  </p:clrMapOvr>
+</p:notes>
+</file>
+
+<file path=ppt/notesSlides/notesSlide4.xml><?xml version="1.0" encoding="utf-8"?>
+<p:notes xmlns:a="http://schemas.openxmlformats.org/drawingml/2006/main" xmlns:p="http://schemas.openxmlformats.org/presentationml/2006/main" xmlns:r="http://schemas.openxmlformats.org/officeDocument/2006/relationships">
+  <p:cSld>
+    <p:spTree>
+      <p:nvGrpSpPr>
+        <p:cNvPr id="1" name=""/>
+        <p:cNvGrpSpPr/>
+        <p:nvPr/>
+      </p:nvGrpSpPr>
+      <p:grpSpPr>
+        <a:xfrm>
+          <a:off x="0" y="0"/>
+          <a:ext cx="0" cy="0"/>
+          <a:chOff x="0" y="0"/>
+          <a:chExt cx="0" cy="0"/>
+        </a:xfrm>
+      </p:grpSpPr>
+      <p:sp>
+        <p:nvSpPr>
+          <p:cNvPr id="2" name="Slide Image Placeholder 1"/>
+          <p:cNvSpPr>
+            <a:spLocks noGrp="1"/>
+          </p:cNvSpPr>
+          <p:nvPr>
+            <p:ph type="sldImg" idx="2"/>
+          </p:nvPr>
+        </p:nvSpPr>
+        <p:spPr/>
+      </p:sp>
+      <p:sp>
+        <p:nvSpPr>
+          <p:cNvPr id="3" name="Notes Placeholder 2"/>
+          <p:cNvSpPr>
+            <a:spLocks noGrp="1"/>
+          </p:cNvSpPr>
+          <p:nvPr>
+            <p:ph type="body" idx="3" sz="quarter"/>
+          </p:nvPr>
+        </p:nvSpPr>
+        <p:spPr/>
+        <p:txBody>
+          <a:bodyPr/>
+          <a:lstStyle/>
+          <a:p>
+            <a:r>
+              <a:t>在座各位應該都知道 RSSI，但我還是簡單對比一下。RSSI 是整個頻帶的總接收功率，是一個純量值，單位 dBm。它告訴你「訊號有多強」，但不告訴你「通道長什麼樣子」。</a:t>
+            </a:r>
+          </a:p>
+          <a:p/>
+          <a:p>
+            <a:r>
+              <a:t>CSI 則是每個 OFDM 子載波的複數增益，包含振幅和相位。802.11n 的情況下，IWL5300 會報告 30 個子載波群組的 CSI。這個資訊豐富多了——你可以從 CSI 重建多路徑傳播特性，這就是為什麼 CSI 可以用於室內定位和手勢辨識，而 RSSI 不行。</a:t>
+            </a:r>
+          </a:p>
+          <a:p/>
+          <a:p>
+            <a:r>
+              <a:t>CSI 的數學表示是頻域通道矩陣 H(f)，對每對 TX-RX 天線各有一個。</a:t>
+            </a:r>
+          </a:p>
+        </p:txBody>
+      </p:sp>
+      <p:sp>
+        <p:nvSpPr>
+          <p:cNvPr id="4" name="Slide Number Placeholder 3"/>
+          <p:cNvSpPr>
+            <a:spLocks noGrp="1"/>
+          </p:cNvSpPr>
+          <p:nvPr>
+            <p:ph type="sldNum" idx="5" sz="quarter"/>
+          </p:nvPr>
+        </p:nvSpPr>
+        <p:spPr/>
+      </p:sp>
+    </p:spTree>
+  </p:cSld>
+  <p:clrMapOvr>
+    <a:masterClrMapping/>
+  </p:clrMapOvr>
+</p:notes>
+</file>
+
+<file path=ppt/notesSlides/notesSlide5.xml><?xml version="1.0" encoding="utf-8"?>
+<p:notes xmlns:a="http://schemas.openxmlformats.org/drawingml/2006/main" xmlns:p="http://schemas.openxmlformats.org/presentationml/2006/main" xmlns:r="http://schemas.openxmlformats.org/officeDocument/2006/relationships">
+  <p:cSld>
+    <p:spTree>
+      <p:nvGrpSpPr>
+        <p:cNvPr id="1" name=""/>
+        <p:cNvGrpSpPr/>
+        <p:nvPr/>
+      </p:nvGrpSpPr>
+      <p:grpSpPr>
+        <a:xfrm>
+          <a:off x="0" y="0"/>
+          <a:ext cx="0" cy="0"/>
+          <a:chOff x="0" y="0"/>
+          <a:chExt cx="0" cy="0"/>
+        </a:xfrm>
+      </p:grpSpPr>
+      <p:sp>
+        <p:nvSpPr>
+          <p:cNvPr id="2" name="Slide Image Placeholder 1"/>
+          <p:cNvSpPr>
+            <a:spLocks noGrp="1"/>
+          </p:cNvSpPr>
+          <p:nvPr>
+            <p:ph type="sldImg" idx="2"/>
+          </p:nvPr>
+        </p:nvSpPr>
+        <p:spPr/>
+      </p:sp>
+      <p:sp>
+        <p:nvSpPr>
+          <p:cNvPr id="3" name="Notes Placeholder 2"/>
+          <p:cNvSpPr>
+            <a:spLocks noGrp="1"/>
+          </p:cNvSpPr>
+          <p:nvPr>
+            <p:ph type="body" idx="3" sz="quarter"/>
+          </p:nvPr>
+        </p:nvSpPr>
+        <p:spPr/>
+        <p:txBody>
+          <a:bodyPr/>
+          <a:lstStyle/>
+          <a:p>
+            <a:r>
+              <a:t>MAC 層的工作是管理「誰可以在什麼時候傳送資料」，以及確保資料的正確性。CSMA/CA 是避免碰撞的機制，ACK 確認每個封包有被收到。</a:t>
+            </a:r>
+          </a:p>
+          <a:p/>
+          <a:p>
+            <a:r>
+              <a:t>這裡有個重要的觀念：MAC 層完全不負責 CSI。CSI 是 PHY 層的 side-channel 資訊，不在 802.11 協定的 MAC frame 定義裡。MAC 層拿到的是已經解調完成的 frame，它不會也不需要知道每個子載波的增益。</a:t>
+            </a:r>
+          </a:p>
+          <a:p/>
+          <a:p>
+            <a:r>
+              <a:t>這是 CSI 在軟體堆疊中「消失」的第一個關卡。</a:t>
+            </a:r>
+          </a:p>
+        </p:txBody>
+      </p:sp>
+      <p:sp>
+        <p:nvSpPr>
+          <p:cNvPr id="4" name="Slide Number Placeholder 3"/>
+          <p:cNvSpPr>
+            <a:spLocks noGrp="1"/>
+          </p:cNvSpPr>
+          <p:nvPr>
+            <p:ph type="sldNum" idx="5" sz="quarter"/>
+          </p:nvPr>
+        </p:nvSpPr>
+        <p:spPr/>
+      </p:sp>
+    </p:spTree>
+  </p:cSld>
+  <p:clrMapOvr>
+    <a:masterClrMapping/>
+  </p:clrMapOvr>
+</p:notes>
+</file>
+
+<file path=ppt/notesSlides/notesSlide6.xml><?xml version="1.0" encoding="utf-8"?>
+<p:notes xmlns:a="http://schemas.openxmlformats.org/drawingml/2006/main" xmlns:p="http://schemas.openxmlformats.org/presentationml/2006/main" xmlns:r="http://schemas.openxmlformats.org/officeDocument/2006/relationships">
+  <p:cSld>
+    <p:spTree>
+      <p:nvGrpSpPr>
+        <p:cNvPr id="1" name=""/>
+        <p:cNvGrpSpPr/>
+        <p:nvPr/>
+      </p:nvGrpSpPr>
+      <p:grpSpPr>
+        <a:xfrm>
+          <a:off x="0" y="0"/>
+          <a:ext cx="0" cy="0"/>
+          <a:chOff x="0" y="0"/>
+          <a:chExt cx="0" cy="0"/>
+        </a:xfrm>
+      </p:grpSpPr>
+      <p:sp>
+        <p:nvSpPr>
+          <p:cNvPr id="2" name="Slide Image Placeholder 1"/>
+          <p:cNvSpPr>
+            <a:spLocks noGrp="1"/>
+          </p:cNvSpPr>
+          <p:nvPr>
+            <p:ph type="sldImg" idx="2"/>
+          </p:nvPr>
+        </p:nvSpPr>
+        <p:spPr/>
+      </p:sp>
+      <p:sp>
+        <p:nvSpPr>
+          <p:cNvPr id="3" name="Notes Placeholder 2"/>
+          <p:cNvSpPr>
+            <a:spLocks noGrp="1"/>
+          </p:cNvSpPr>
+          <p:nvPr>
+            <p:ph type="body" idx="3" sz="quarter"/>
+          </p:nvPr>
+        </p:nvSpPr>
+        <p:spPr/>
+        <p:txBody>
+          <a:bodyPr/>
+          <a:lstStyle/>
+          <a:p>
+            <a:r>
+              <a:t>這張表是今天的地圖，後面的所有討論都會對應回這張表。</a:t>
+            </a:r>
+          </a:p>
+          <a:p/>
+          <a:p>
+            <a:r>
+              <a:t>最重要的觀察：CSI 存在於 L1（PHY 硬體），但 Windows 的軟體介面從 L2a 才開始（nwifi.sys 和 OEM.sys）。L1 和 L2a 之間沒有標準的橋接機制來傳遞 CSI。</a:t>
+            </a:r>
+          </a:p>
+          <a:p/>
+          <a:p>
+            <a:r>
+              <a:t>右邊的 Windows 元件欄位就是我們接下來要深入討論的每一個元件。請記住這個對應關係。</a:t>
+            </a:r>
+          </a:p>
+        </p:txBody>
+      </p:sp>
+      <p:sp>
+        <p:nvSpPr>
+          <p:cNvPr id="4" name="Slide Number Placeholder 3"/>
+          <p:cNvSpPr>
+            <a:spLocks noGrp="1"/>
+          </p:cNvSpPr>
+          <p:nvPr>
+            <p:ph type="sldNum" idx="5" sz="quarter"/>
+          </p:nvPr>
+        </p:nvSpPr>
+        <p:spPr/>
+      </p:sp>
+    </p:spTree>
+  </p:cSld>
+  <p:clrMapOvr>
+    <a:masterClrMapping/>
+  </p:clrMapOvr>
+</p:notes>
+</file>
+
+<file path=ppt/notesSlides/notesSlide7.xml><?xml version="1.0" encoding="utf-8"?>
+<p:notes xmlns:a="http://schemas.openxmlformats.org/drawingml/2006/main" xmlns:p="http://schemas.openxmlformats.org/presentationml/2006/main" xmlns:r="http://schemas.openxmlformats.org/officeDocument/2006/relationships">
+  <p:cSld>
+    <p:spTree>
+      <p:nvGrpSpPr>
+        <p:cNvPr id="1" name=""/>
+        <p:cNvGrpSpPr/>
+        <p:nvPr/>
+      </p:nvGrpSpPr>
+      <p:grpSpPr>
+        <a:xfrm>
+          <a:off x="0" y="0"/>
+          <a:ext cx="0" cy="0"/>
+          <a:chOff x="0" y="0"/>
+          <a:chExt cx="0" cy="0"/>
+        </a:xfrm>
+      </p:grpSpPr>
+      <p:sp>
+        <p:nvSpPr>
+          <p:cNvPr id="2" name="Slide Image Placeholder 1"/>
+          <p:cNvSpPr>
+            <a:spLocks noGrp="1"/>
+          </p:cNvSpPr>
+          <p:nvPr>
+            <p:ph type="sldImg" idx="2"/>
+          </p:nvPr>
+        </p:nvSpPr>
+        <p:spPr/>
+      </p:sp>
+      <p:sp>
+        <p:nvSpPr>
+          <p:cNvPr id="3" name="Notes Placeholder 2"/>
+          <p:cNvSpPr>
+            <a:spLocks noGrp="1"/>
+          </p:cNvSpPr>
+          <p:nvPr>
+            <p:ph type="body" idx="3" sz="quarter"/>
+          </p:nvPr>
+        </p:nvSpPr>
+        <p:spPr/>
+        <p:txBody>
+          <a:bodyPr/>
+          <a:lstStyle/>
+          <a:p>
+            <a:r>
+              <a:t>現在進入 Windows 驅動架構。這張堆疊圖從上到下代表從應用程式到硬體的路徑。</a:t>
+            </a:r>
+          </a:p>
+          <a:p/>
+          <a:p>
+            <a:r>
+              <a:t>顏色區分了三個層次：綠色是 User Mode（使用者模式），藍色和紫色是 Kernel Mode（核心模式），最底層是硬體。</a:t>
+            </a:r>
+          </a:p>
+          <a:p/>
+          <a:p>
+            <a:r>
+              <a:t>每一層只能和相鄰層溝通，而且必須透過明確定義的介面。這個設計保證了穩定性，但也意味著 L1 的 PHY 資訊沒有辦法「跳過」中間層直接到應用程式。</a:t>
+            </a:r>
+          </a:p>
+          <a:p/>
+          <a:p>
+            <a:r>
+              <a:t>接下來我們逐層解釋，重點在紅色的 OEM.sys 和紫色的 nwifi.sys。</a:t>
+            </a:r>
+          </a:p>
+        </p:txBody>
+      </p:sp>
+      <p:sp>
+        <p:nvSpPr>
+          <p:cNvPr id="4" name="Slide Number Placeholder 3"/>
+          <p:cNvSpPr>
+            <a:spLocks noGrp="1"/>
+          </p:cNvSpPr>
+          <p:nvPr>
+            <p:ph type="sldNum" idx="5" sz="quarter"/>
+          </p:nvPr>
+        </p:nvSpPr>
+        <p:spPr/>
+      </p:sp>
+    </p:spTree>
+  </p:cSld>
+  <p:clrMapOvr>
+    <a:masterClrMapping/>
+  </p:clrMapOvr>
+</p:notes>
+</file>
+
+<file path=ppt/notesSlides/notesSlide8.xml><?xml version="1.0" encoding="utf-8"?>
+<p:notes xmlns:a="http://schemas.openxmlformats.org/drawingml/2006/main" xmlns:p="http://schemas.openxmlformats.org/presentationml/2006/main" xmlns:r="http://schemas.openxmlformats.org/officeDocument/2006/relationships">
+  <p:cSld>
+    <p:spTree>
+      <p:nvGrpSpPr>
+        <p:cNvPr id="1" name=""/>
+        <p:cNvGrpSpPr/>
+        <p:nvPr/>
+      </p:nvGrpSpPr>
+      <p:grpSpPr>
+        <a:xfrm>
+          <a:off x="0" y="0"/>
+          <a:ext cx="0" cy="0"/>
+          <a:chOff x="0" y="0"/>
+          <a:chExt cx="0" cy="0"/>
+        </a:xfrm>
+      </p:grpSpPr>
+      <p:sp>
+        <p:nvSpPr>
+          <p:cNvPr id="2" name="Slide Image Placeholder 1"/>
+          <p:cNvSpPr>
+            <a:spLocks noGrp="1"/>
+          </p:cNvSpPr>
+          <p:nvPr>
+            <p:ph type="sldImg" idx="2"/>
+          </p:nvPr>
+        </p:nvSpPr>
+        <p:spPr/>
+      </p:sp>
+      <p:sp>
+        <p:nvSpPr>
+          <p:cNvPr id="3" name="Notes Placeholder 2"/>
+          <p:cNvSpPr>
+            <a:spLocks noGrp="1"/>
+          </p:cNvSpPr>
+          <p:nvPr>
+            <p:ph type="body" idx="3" sz="quarter"/>
+          </p:nvPr>
+        </p:nvSpPr>
+        <p:spPr/>
+        <p:txBody>
+          <a:bodyPr/>
+          <a:lstStyle/>
+          <a:p>
+            <a:r>
+              <a:t>OEM.sys 是網卡廠商提供的 Miniport Driver，是整個 Windows 網路堆疊中距離硬體最近的軟體元件。</a:t>
+            </a:r>
+          </a:p>
+          <a:p/>
+          <a:p>
+            <a:r>
+              <a:t>它透過 MMIO 或 PCI 介面直接讀寫網卡的硬體暫存器，可以控制 RF 參數像是頻道和 TX 功率，也負責管理 DMA 傳輸。</a:t>
+            </a:r>
+          </a:p>
+          <a:p/>
+          <a:p>
+            <a:r>
+              <a:t>右邊的例子列出各廠商的驅動名稱。Intel 在 Linux 上叫 iwlwifi，但在 Windows 上叫 netwtw*.sys，星號代表版本號。</a:t>
+            </a:r>
+          </a:p>
+          <a:p/>
+          <a:p>
+            <a:r>
+              <a:t>這裡有一個關鍵觀察：OEM.sys 理論上可以讀取 NIC 韌體計算的 CSI 資料，因為它有直接訪問硬體暫存器的能力。問題是它選擇不向上層暴露這個資料。</a:t>
+            </a:r>
+          </a:p>
+        </p:txBody>
+      </p:sp>
+      <p:sp>
+        <p:nvSpPr>
+          <p:cNvPr id="4" name="Slide Number Placeholder 3"/>
+          <p:cNvSpPr>
+            <a:spLocks noGrp="1"/>
+          </p:cNvSpPr>
+          <p:nvPr>
+            <p:ph type="sldNum" idx="5" sz="quarter"/>
+          </p:nvPr>
+        </p:nvSpPr>
+        <p:spPr/>
+      </p:sp>
+    </p:spTree>
+  </p:cSld>
+  <p:clrMapOvr>
+    <a:masterClrMapping/>
+  </p:clrMapOvr>
+</p:notes>
+</file>
+
+<file path=ppt/notesSlides/notesSlide9.xml><?xml version="1.0" encoding="utf-8"?>
+<p:notes xmlns:a="http://schemas.openxmlformats.org/drawingml/2006/main" xmlns:p="http://schemas.openxmlformats.org/presentationml/2006/main" xmlns:r="http://schemas.openxmlformats.org/officeDocument/2006/relationships">
+  <p:cSld>
+    <p:spTree>
+      <p:nvGrpSpPr>
+        <p:cNvPr id="1" name=""/>
+        <p:cNvGrpSpPr/>
+        <p:nvPr/>
+      </p:nvGrpSpPr>
+      <p:grpSpPr>
+        <a:xfrm>
+          <a:off x="0" y="0"/>
+          <a:ext cx="0" cy="0"/>
+          <a:chOff x="0" y="0"/>
+          <a:chExt cx="0" cy="0"/>
+        </a:xfrm>
+      </p:grpSpPr>
+      <p:sp>
+        <p:nvSpPr>
+          <p:cNvPr id="2" name="Slide Image Placeholder 1"/>
+          <p:cNvSpPr>
+            <a:spLocks noGrp="1"/>
+          </p:cNvSpPr>
+          <p:nvPr>
+            <p:ph type="sldImg" idx="2"/>
+          </p:nvPr>
+        </p:nvSpPr>
+        <p:spPr/>
+      </p:sp>
+      <p:sp>
+        <p:nvSpPr>
+          <p:cNvPr id="3" name="Notes Placeholder 2"/>
+          <p:cNvSpPr>
+            <a:spLocks noGrp="1"/>
+          </p:cNvSpPr>
+          <p:nvPr>
+            <p:ph type="body" idx="3" sz="quarter"/>
+          </p:nvPr>
+        </p:nvSpPr>
+        <p:spPr/>
+        <p:txBody>
+          <a:bodyPr/>
+          <a:lstStyle/>
+          <a:p>
+            <a:r>
+              <a:t>這張流程圖展示了一個 RX 封包從 NIC 韌體到應用層的路徑。</a:t>
+            </a:r>
+          </a:p>
+          <a:p/>
+          <a:p>
+            <a:r>
+              <a:t>注意最左邊：NIC 韌體計算 CSI 後，把結果儲存在硬體暫存器。OEM.sys 透過 DMA 讀取 RX 封包緩衝區，但這個緩衝區裡只有 802.11 frame 的內容，不含 CSI。</a:t>
+            </a:r>
+          </a:p>
+          <a:p/>
+          <a:p>
+            <a:r>
+              <a:t>CSI 從來沒有進入 NDIS_NET_BUFFER 這個標準封包結構。換句話說，CSI 在 OEM.sys 這一步就已經被排除在資料流之外了。</a:t>
+            </a:r>
+          </a:p>
+          <a:p/>
+          <a:p>
+            <a:r>
+              <a:t>這就是 CSI 消失的根本原因：不是某個軟體元件「擋住」了 CSI，而是 CSI 從一開始就沒有被放進標準的資料傳輸路徑。</a:t>
+            </a:r>
+          </a:p>
+        </p:txBody>
+      </p:sp>
+      <p:sp>
+        <p:nvSpPr>
+          <p:cNvPr id="4" name="Slide Number Placeholder 3"/>
+          <p:cNvSpPr>
+            <a:spLocks noGrp="1"/>
+          </p:cNvSpPr>
+          <p:nvPr>
+            <p:ph type="sldNum" idx="5" sz="quarter"/>
+          </p:nvPr>
+        </p:nvSpPr>
+        <p:spPr/>
+      </p:sp>
+    </p:spTree>
+  </p:cSld>
+  <p:clrMapOvr>
+    <a:masterClrMapping/>
+  </p:clrMapOvr>
+</p:notes>
 </file>
 
 <file path=ppt/slideLayouts/slideLayout1.xml><?xml version="1.0" encoding="utf-8"?>
@@ -15637,4 +18163,324 @@
   </a:objectDefaults>
   <a:extraClrSchemeLst/>
 </a:theme>
+</file>
+
+<file path=ppt/theme/theme2.xml><?xml version="1.0" encoding="utf-8"?>
+<a:theme xmlns:a="http://schemas.openxmlformats.org/drawingml/2006/main" name="Office Theme">
+  <a:themeElements>
+    <a:clrScheme name="Office">
+      <a:dk1>
+        <a:sysClr val="windowText" lastClr="000000"/>
+      </a:dk1>
+      <a:lt1>
+        <a:sysClr val="window" lastClr="FFFFFF"/>
+      </a:lt1>
+      <a:dk2>
+        <a:srgbClr val="1F497D"/>
+      </a:dk2>
+      <a:lt2>
+        <a:srgbClr val="EEECE1"/>
+      </a:lt2>
+      <a:accent1>
+        <a:srgbClr val="4F81BD"/>
+      </a:accent1>
+      <a:accent2>
+        <a:srgbClr val="C0504D"/>
+      </a:accent2>
+      <a:accent3>
+        <a:srgbClr val="9BBB59"/>
+      </a:accent3>
+      <a:accent4>
+        <a:srgbClr val="8064A2"/>
+      </a:accent4>
+      <a:accent5>
+        <a:srgbClr val="4BACC6"/>
+      </a:accent5>
+      <a:accent6>
+        <a:srgbClr val="F79646"/>
+      </a:accent6>
+      <a:hlink>
+        <a:srgbClr val="0000FF"/>
+      </a:hlink>
+      <a:folHlink>
+        <a:srgbClr val="800080"/>
+      </a:folHlink>
+    </a:clrScheme>
+    <a:fontScheme name="Office">
+      <a:majorFont>
+        <a:latin typeface="Calibri"/>
+        <a:ea typeface=""/>
+        <a:cs typeface=""/>
+        <a:font script="Jpan" typeface="ＭＳ Ｐゴシック"/>
+        <a:font script="Hang" typeface="맑은 고딕"/>
+        <a:font script="Hans" typeface="宋体"/>
+        <a:font script="Hant" typeface="新細明體"/>
+        <a:font script="Arab" typeface="Times New Roman"/>
+        <a:font script="Hebr" typeface="Times New Roman"/>
+        <a:font script="Thai" typeface="Angsana New"/>
+        <a:font script="Ethi" typeface="Nyala"/>
+        <a:font script="Beng" typeface="Vrinda"/>
+        <a:font script="Gujr" typeface="Shruti"/>
+        <a:font script="Khmr" typeface="MoolBoran"/>
+        <a:font script="Knda" typeface="Tunga"/>
+        <a:font script="Guru" typeface="Raavi"/>
+        <a:font script="Cans" typeface="Euphemia"/>
+        <a:font script="Cher" typeface="Plantagenet Cherokee"/>
+        <a:font script="Yiii" typeface="Microsoft Yi Baiti"/>
+        <a:font script="Tibt" typeface="Microsoft Himalaya"/>
+        <a:font script="Thaa" typeface="MV Boli"/>
+        <a:font script="Deva" typeface="Mangal"/>
+        <a:font script="Telu" typeface="Gautami"/>
+        <a:font script="Taml" typeface="Latha"/>
+        <a:font script="Syrc" typeface="Estrangelo Edessa"/>
+        <a:font script="Orya" typeface="Kalinga"/>
+        <a:font script="Mlym" typeface="Kartika"/>
+        <a:font script="Laoo" typeface="DokChampa"/>
+        <a:font script="Sinh" typeface="Iskoola Pota"/>
+        <a:font script="Mong" typeface="Mongolian Baiti"/>
+        <a:font script="Viet" typeface="Times New Roman"/>
+        <a:font script="Uigh" typeface="Microsoft Uighur"/>
+        <a:font script="Geor" typeface="Sylfaen"/>
+      </a:majorFont>
+      <a:minorFont>
+        <a:latin typeface="Calibri"/>
+        <a:ea typeface=""/>
+        <a:cs typeface=""/>
+        <a:font script="Jpan" typeface="ＭＳ Ｐゴシック"/>
+        <a:font script="Hang" typeface="맑은 고딕"/>
+        <a:font script="Hans" typeface="宋体"/>
+        <a:font script="Hant" typeface="新細明體"/>
+        <a:font script="Arab" typeface="Arial"/>
+        <a:font script="Hebr" typeface="Arial"/>
+        <a:font script="Thai" typeface="Cordia New"/>
+        <a:font script="Ethi" typeface="Nyala"/>
+        <a:font script="Beng" typeface="Vrinda"/>
+        <a:font script="Gujr" typeface="Shruti"/>
+        <a:font script="Khmr" typeface="DaunPenh"/>
+        <a:font script="Knda" typeface="Tunga"/>
+        <a:font script="Guru" typeface="Raavi"/>
+        <a:font script="Cans" typeface="Euphemia"/>
+        <a:font script="Cher" typeface="Plantagenet Cherokee"/>
+        <a:font script="Yiii" typeface="Microsoft Yi Baiti"/>
+        <a:font script="Tibt" typeface="Microsoft Himalaya"/>
+        <a:font script="Thaa" typeface="MV Boli"/>
+        <a:font script="Deva" typeface="Mangal"/>
+        <a:font script="Telu" typeface="Gautami"/>
+        <a:font script="Taml" typeface="Latha"/>
+        <a:font script="Syrc" typeface="Estrangelo Edessa"/>
+        <a:font script="Orya" typeface="Kalinga"/>
+        <a:font script="Mlym" typeface="Kartika"/>
+        <a:font script="Laoo" typeface="DokChampa"/>
+        <a:font script="Sinh" typeface="Iskoola Pota"/>
+        <a:font script="Mong" typeface="Mongolian Baiti"/>
+        <a:font script="Viet" typeface="Arial"/>
+        <a:font script="Uigh" typeface="Microsoft Uighur"/>
+        <a:font script="Geor" typeface="Sylfaen"/>
+      </a:minorFont>
+    </a:fontScheme>
+    <a:fmtScheme name="Office">
+      <a:fillStyleLst>
+        <a:solidFill>
+          <a:schemeClr val="phClr"/>
+        </a:solidFill>
+        <a:gradFill rotWithShape="1">
+          <a:gsLst>
+            <a:gs pos="0">
+              <a:schemeClr val="phClr">
+                <a:tint val="50000"/>
+                <a:satMod val="300000"/>
+              </a:schemeClr>
+            </a:gs>
+            <a:gs pos="35000">
+              <a:schemeClr val="phClr">
+                <a:tint val="37000"/>
+                <a:satMod val="300000"/>
+              </a:schemeClr>
+            </a:gs>
+            <a:gs pos="100000">
+              <a:schemeClr val="phClr">
+                <a:tint val="15000"/>
+                <a:satMod val="350000"/>
+              </a:schemeClr>
+            </a:gs>
+          </a:gsLst>
+          <a:lin ang="16200000" scaled="1"/>
+        </a:gradFill>
+        <a:gradFill rotWithShape="1">
+          <a:gsLst>
+            <a:gs pos="0">
+              <a:schemeClr val="phClr">
+                <a:tint val="100000"/>
+                <a:shade val="100000"/>
+                <a:satMod val="130000"/>
+              </a:schemeClr>
+            </a:gs>
+            <a:gs pos="100000">
+              <a:schemeClr val="phClr">
+                <a:tint val="50000"/>
+                <a:shade val="100000"/>
+                <a:satMod val="350000"/>
+              </a:schemeClr>
+            </a:gs>
+          </a:gsLst>
+          <a:lin ang="16200000" scaled="0"/>
+        </a:gradFill>
+      </a:fillStyleLst>
+      <a:lnStyleLst>
+        <a:ln w="9525" cap="flat" cmpd="sng" algn="ctr">
+          <a:solidFill>
+            <a:schemeClr val="phClr">
+              <a:shade val="95000"/>
+              <a:satMod val="105000"/>
+            </a:schemeClr>
+          </a:solidFill>
+          <a:prstDash val="solid"/>
+        </a:ln>
+        <a:ln w="25400" cap="flat" cmpd="sng" algn="ctr">
+          <a:solidFill>
+            <a:schemeClr val="phClr"/>
+          </a:solidFill>
+          <a:prstDash val="solid"/>
+        </a:ln>
+        <a:ln w="38100" cap="flat" cmpd="sng" algn="ctr">
+          <a:solidFill>
+            <a:schemeClr val="phClr"/>
+          </a:solidFill>
+          <a:prstDash val="solid"/>
+        </a:ln>
+      </a:lnStyleLst>
+      <a:effectStyleLst>
+        <a:effectStyle>
+          <a:effectLst>
+            <a:outerShdw blurRad="40000" dist="20000" dir="5400000" rotWithShape="0">
+              <a:srgbClr val="000000">
+                <a:alpha val="38000"/>
+              </a:srgbClr>
+            </a:outerShdw>
+          </a:effectLst>
+        </a:effectStyle>
+        <a:effectStyle>
+          <a:effectLst>
+            <a:outerShdw blurRad="40000" dist="23000" dir="5400000" rotWithShape="0">
+              <a:srgbClr val="000000">
+                <a:alpha val="35000"/>
+              </a:srgbClr>
+            </a:outerShdw>
+          </a:effectLst>
+        </a:effectStyle>
+        <a:effectStyle>
+          <a:effectLst>
+            <a:outerShdw blurRad="40000" dist="23000" dir="5400000" rotWithShape="0">
+              <a:srgbClr val="000000">
+                <a:alpha val="35000"/>
+              </a:srgbClr>
+            </a:outerShdw>
+          </a:effectLst>
+          <a:scene3d>
+            <a:camera prst="orthographicFront">
+              <a:rot lat="0" lon="0" rev="0"/>
+            </a:camera>
+            <a:lightRig rig="threePt" dir="t">
+              <a:rot lat="0" lon="0" rev="1200000"/>
+            </a:lightRig>
+          </a:scene3d>
+          <a:sp3d>
+            <a:bevelT w="63500" h="25400"/>
+          </a:sp3d>
+        </a:effectStyle>
+      </a:effectStyleLst>
+      <a:bgFillStyleLst>
+        <a:solidFill>
+          <a:schemeClr val="phClr"/>
+        </a:solidFill>
+        <a:gradFill rotWithShape="1">
+          <a:gsLst>
+            <a:gs pos="0">
+              <a:schemeClr val="phClr">
+                <a:tint val="40000"/>
+                <a:satMod val="350000"/>
+              </a:schemeClr>
+            </a:gs>
+            <a:gs pos="40000">
+              <a:schemeClr val="phClr">
+                <a:tint val="45000"/>
+                <a:shade val="99000"/>
+                <a:satMod val="350000"/>
+              </a:schemeClr>
+            </a:gs>
+            <a:gs pos="100000">
+              <a:schemeClr val="phClr">
+                <a:shade val="20000"/>
+                <a:satMod val="255000"/>
+              </a:schemeClr>
+            </a:gs>
+          </a:gsLst>
+          <a:path path="circle">
+            <a:fillToRect l="50000" t="-80000" r="50000" b="180000"/>
+          </a:path>
+        </a:gradFill>
+        <a:gradFill rotWithShape="1">
+          <a:gsLst>
+            <a:gs pos="0">
+              <a:schemeClr val="phClr">
+                <a:tint val="80000"/>
+                <a:satMod val="300000"/>
+              </a:schemeClr>
+            </a:gs>
+            <a:gs pos="100000">
+              <a:schemeClr val="phClr">
+                <a:shade val="30000"/>
+                <a:satMod val="200000"/>
+              </a:schemeClr>
+            </a:gs>
+          </a:gsLst>
+          <a:path path="circle">
+            <a:fillToRect l="50000" t="50000" r="50000" b="50000"/>
+          </a:path>
+        </a:gradFill>
+      </a:bgFillStyleLst>
+    </a:fmtScheme>
+  </a:themeElements>
+  <a:objectDefaults>
+    <a:spDef>
+      <a:spPr/>
+      <a:bodyPr/>
+      <a:lstStyle/>
+      <a:style>
+        <a:lnRef idx="1">
+          <a:schemeClr val="accent1"/>
+        </a:lnRef>
+        <a:fillRef idx="3">
+          <a:schemeClr val="accent1"/>
+        </a:fillRef>
+        <a:effectRef idx="2">
+          <a:schemeClr val="accent1"/>
+        </a:effectRef>
+        <a:fontRef idx="minor">
+          <a:schemeClr val="lt1"/>
+        </a:fontRef>
+      </a:style>
+    </a:spDef>
+    <a:lnDef>
+      <a:spPr/>
+      <a:bodyPr/>
+      <a:lstStyle/>
+      <a:style>
+        <a:lnRef idx="2">
+          <a:schemeClr val="accent1"/>
+        </a:lnRef>
+        <a:fillRef idx="0">
+          <a:schemeClr val="accent1"/>
+        </a:fillRef>
+        <a:effectRef idx="1">
+          <a:schemeClr val="accent1"/>
+        </a:effectRef>
+        <a:fontRef idx="minor">
+          <a:schemeClr val="tx1"/>
+        </a:fontRef>
+      </a:style>
+    </a:lnDef>
+  </a:objectDefaults>
+  <a:extraClrSchemeLst/>
+</a:theme>
 </file>
</xml_diff>

<commit_message>
fix: immutable slide data, move imports to top, distinct section 1 color
</commit_message>
<xml_diff>
--- a/output/network-card-csi.pptx
+++ b/output/network-card-csi.pptx
@@ -16630,7 +16630,7 @@
             <a:avLst/>
           </a:prstGeom>
           <a:solidFill>
-            <a:srgbClr val="4A9EFF"/>
+            <a:srgbClr val="29B6F6"/>
           </a:solidFill>
           <a:ln>
             <a:noFill/>
@@ -16684,7 +16684,7 @@
             <a:r>
               <a:rPr sz="3600" b="1">
                 <a:solidFill>
-                  <a:srgbClr val="4A9EFF"/>
+                  <a:srgbClr val="29B6F6"/>
                 </a:solidFill>
                 <a:latin typeface="Calibri"/>
               </a:rPr>
@@ -16709,7 +16709,7 @@
           </a:prstGeom>
           <a:ln w="19050">
             <a:solidFill>
-              <a:srgbClr val="4A9EFF"/>
+              <a:srgbClr val="29B6F6"/>
             </a:solidFill>
           </a:ln>
         </p:spPr>
@@ -17414,7 +17414,7 @@
             <a:r>
               <a:rPr sz="1200" b="0">
                 <a:solidFill>
-                  <a:srgbClr val="4A9EFF"/>
+                  <a:srgbClr val="29B6F6"/>
                 </a:solidFill>
                 <a:latin typeface="Calibri"/>
               </a:rPr>
@@ -17464,7 +17464,7 @@
             <a:avLst/>
           </a:prstGeom>
           <a:solidFill>
-            <a:srgbClr val="4A9EFF"/>
+            <a:srgbClr val="29B6F6"/>
           </a:solidFill>
           <a:ln>
             <a:noFill/>
@@ -17518,7 +17518,7 @@
             <a:r>
               <a:rPr sz="3600" b="1">
                 <a:solidFill>
-                  <a:srgbClr val="4A9EFF"/>
+                  <a:srgbClr val="29B6F6"/>
                 </a:solidFill>
                 <a:latin typeface="Calibri"/>
               </a:rPr>
@@ -17543,7 +17543,7 @@
           </a:prstGeom>
           <a:ln w="19050">
             <a:solidFill>
-              <a:srgbClr val="4A9EFF"/>
+              <a:srgbClr val="29B6F6"/>
             </a:solidFill>
           </a:ln>
         </p:spPr>
@@ -17864,7 +17864,7 @@
             <a:r>
               <a:rPr sz="1200" b="0">
                 <a:solidFill>
-                  <a:srgbClr val="4A9EFF"/>
+                  <a:srgbClr val="29B6F6"/>
                 </a:solidFill>
                 <a:latin typeface="Calibri"/>
               </a:rPr>
@@ -17914,7 +17914,7 @@
             <a:avLst/>
           </a:prstGeom>
           <a:solidFill>
-            <a:srgbClr val="4A9EFF"/>
+            <a:srgbClr val="29B6F6"/>
           </a:solidFill>
           <a:ln>
             <a:noFill/>
@@ -17968,7 +17968,7 @@
             <a:r>
               <a:rPr sz="3600" b="1">
                 <a:solidFill>
-                  <a:srgbClr val="4A9EFF"/>
+                  <a:srgbClr val="29B6F6"/>
                 </a:solidFill>
                 <a:latin typeface="Calibri"/>
               </a:rPr>
@@ -17993,7 +17993,7 @@
           </a:prstGeom>
           <a:ln w="19050">
             <a:solidFill>
-              <a:srgbClr val="4A9EFF"/>
+              <a:srgbClr val="29B6F6"/>
             </a:solidFill>
           </a:ln>
         </p:spPr>
@@ -18111,7 +18111,7 @@
             <a:r>
               <a:rPr sz="1200" b="0">
                 <a:solidFill>
-                  <a:srgbClr val="4A9EFF"/>
+                  <a:srgbClr val="29B6F6"/>
                 </a:solidFill>
                 <a:latin typeface="Calibri"/>
               </a:rPr>
@@ -18161,7 +18161,7 @@
             <a:avLst/>
           </a:prstGeom>
           <a:solidFill>
-            <a:srgbClr val="4A9EFF"/>
+            <a:srgbClr val="29B6F6"/>
           </a:solidFill>
           <a:ln>
             <a:noFill/>
@@ -18215,7 +18215,7 @@
             <a:r>
               <a:rPr sz="3600" b="1">
                 <a:solidFill>
-                  <a:srgbClr val="4A9EFF"/>
+                  <a:srgbClr val="29B6F6"/>
                 </a:solidFill>
                 <a:latin typeface="Calibri"/>
               </a:rPr>
@@ -18240,7 +18240,7 @@
           </a:prstGeom>
           <a:ln w="19050">
             <a:solidFill>
-              <a:srgbClr val="4A9EFF"/>
+              <a:srgbClr val="29B6F6"/>
             </a:solidFill>
           </a:ln>
         </p:spPr>
@@ -18389,7 +18389,7 @@
             <a:r>
               <a:rPr sz="1200" b="0">
                 <a:solidFill>
-                  <a:srgbClr val="4A9EFF"/>
+                  <a:srgbClr val="29B6F6"/>
                 </a:solidFill>
                 <a:latin typeface="Calibri"/>
               </a:rPr>
@@ -18439,7 +18439,7 @@
             <a:avLst/>
           </a:prstGeom>
           <a:solidFill>
-            <a:srgbClr val="4A9EFF"/>
+            <a:srgbClr val="29B6F6"/>
           </a:solidFill>
           <a:ln>
             <a:noFill/>
@@ -18493,7 +18493,7 @@
             <a:r>
               <a:rPr sz="3600" b="1">
                 <a:solidFill>
-                  <a:srgbClr val="4A9EFF"/>
+                  <a:srgbClr val="29B6F6"/>
                 </a:solidFill>
                 <a:latin typeface="Calibri"/>
               </a:rPr>
@@ -18518,7 +18518,7 @@
           </a:prstGeom>
           <a:ln w="19050">
             <a:solidFill>
-              <a:srgbClr val="4A9EFF"/>
+              <a:srgbClr val="29B6F6"/>
             </a:solidFill>
           </a:ln>
         </p:spPr>
@@ -19260,7 +19260,7 @@
             <a:r>
               <a:rPr sz="1200" b="0">
                 <a:solidFill>
-                  <a:srgbClr val="4A9EFF"/>
+                  <a:srgbClr val="29B6F6"/>
                 </a:solidFill>
                 <a:latin typeface="Calibri"/>
               </a:rPr>

</xml_diff>